<commit_message>
Add QR codes to Westlake PPT
</commit_message>
<xml_diff>
--- a/public/materials/Qi_Heng_Interview_Presentation.pptx
+++ b/public/materials/Qi_Heng_Interview_Presentation.pptx
@@ -3361,7 +3361,7 @@
         </p:nvSpPr>
         <p:spPr>
           <a:xfrm>
-            <a:off x="8668512" y="5230368"/>
+            <a:off x="8668512" y="5047488"/>
             <a:ext cx="1508760" cy="310896"/>
           </a:xfrm>
           <a:prstGeom prst="roundRect">
@@ -3406,7 +3406,7 @@
         </p:nvSpPr>
         <p:spPr>
           <a:xfrm>
-            <a:off x="8741664" y="5312664"/>
+            <a:off x="8741664" y="5129783"/>
             <a:ext cx="1362456" cy="137160"/>
           </a:xfrm>
           <a:prstGeom prst="rect">
@@ -3426,7 +3426,7 @@
               </a:lnSpc>
             </a:pPr>
             <a:r>
-              <a:rPr sz="850" b="1">
+              <a:rPr sz="919" b="1">
                 <a:solidFill>
                   <a:srgbClr val="127584"/>
                 </a:solidFill>
@@ -3445,7 +3445,7 @@
         </p:nvSpPr>
         <p:spPr>
           <a:xfrm>
-            <a:off x="10314432" y="5230368"/>
+            <a:off x="10314432" y="5047488"/>
             <a:ext cx="1225296" cy="310896"/>
           </a:xfrm>
           <a:prstGeom prst="roundRect">
@@ -3490,7 +3490,7 @@
         </p:nvSpPr>
         <p:spPr>
           <a:xfrm>
-            <a:off x="10387584" y="5312664"/>
+            <a:off x="10387584" y="5129783"/>
             <a:ext cx="1078992" cy="137160"/>
           </a:xfrm>
           <a:prstGeom prst="rect">
@@ -3510,7 +3510,7 @@
               </a:lnSpc>
             </a:pPr>
             <a:r>
-              <a:rPr sz="850" b="1">
+              <a:rPr sz="919" b="1">
                 <a:solidFill>
                   <a:srgbClr val="4F805E"/>
                 </a:solidFill>
@@ -3523,7 +3523,193 @@
       </p:sp>
       <p:sp>
         <p:nvSpPr>
-          <p:cNvPr id="13" name="Rectangle 12"/>
+          <p:cNvPr id="13" name="Rounded Rectangle 12"/>
+          <p:cNvSpPr/>
+          <p:nvPr/>
+        </p:nvSpPr>
+        <p:spPr>
+          <a:xfrm>
+            <a:off x="8805672" y="5486400"/>
+            <a:ext cx="859536" cy="859536"/>
+          </a:xfrm>
+          <a:prstGeom prst="roundRect">
+            <a:avLst/>
+          </a:prstGeom>
+          <a:solidFill>
+            <a:srgbClr val="EFF7F8"/>
+          </a:solidFill>
+          <a:ln w="8890">
+            <a:solidFill>
+              <a:srgbClr val="C8DDE1"/>
+            </a:solidFill>
+          </a:ln>
+        </p:spPr>
+        <p:style>
+          <a:lnRef idx="1">
+            <a:schemeClr val="accent1"/>
+          </a:lnRef>
+          <a:fillRef idx="3">
+            <a:schemeClr val="accent1"/>
+          </a:fillRef>
+          <a:effectRef idx="2">
+            <a:schemeClr val="accent1"/>
+          </a:effectRef>
+          <a:fontRef idx="minor">
+            <a:schemeClr val="lt1"/>
+          </a:fontRef>
+        </p:style>
+        <p:txBody>
+          <a:bodyPr rtlCol="0" anchor="ctr"/>
+          <a:lstStyle/>
+          <a:p>
+            <a:pPr algn="ctr"/>
+          </a:p>
+        </p:txBody>
+      </p:sp>
+      <p:pic>
+        <p:nvPicPr>
+          <p:cNvPr id="14" name="Picture 13" descr="homepage_qr.png"/>
+          <p:cNvPicPr>
+            <a:picLocks noChangeAspect="1"/>
+          </p:cNvPicPr>
+          <p:nvPr/>
+        </p:nvPicPr>
+        <p:blipFill>
+          <a:blip r:embed="rId4"/>
+          <a:stretch>
+            <a:fillRect/>
+          </a:stretch>
+        </p:blipFill>
+        <p:spPr>
+          <a:xfrm>
+            <a:off x="8860536" y="5541264"/>
+            <a:ext cx="749808" cy="749808"/>
+          </a:xfrm>
+          <a:prstGeom prst="rect">
+            <a:avLst/>
+          </a:prstGeom>
+        </p:spPr>
+      </p:pic>
+      <p:sp>
+        <p:nvSpPr>
+          <p:cNvPr id="15" name="TextBox 14"/>
+          <p:cNvSpPr txBox="1"/>
+          <p:nvPr/>
+        </p:nvSpPr>
+        <p:spPr>
+          <a:xfrm>
+            <a:off x="8714232" y="6400800"/>
+            <a:ext cx="1060704" cy="182880"/>
+          </a:xfrm>
+          <a:prstGeom prst="rect">
+            <a:avLst/>
+          </a:prstGeom>
+          <a:noFill/>
+        </p:spPr>
+        <p:txBody>
+          <a:bodyPr wrap="square" lIns="18288" rIns="18288" tIns="9144" bIns="9144" anchor="t">
+            <a:spAutoFit/>
+          </a:bodyPr>
+          <a:lstStyle/>
+          <a:p>
+            <a:pPr algn="ctr">
+              <a:lnSpc>
+                <a:spcPct val="108000"/>
+              </a:lnSpc>
+            </a:pPr>
+            <a:r>
+              <a:rPr sz="880" b="1">
+                <a:solidFill>
+                  <a:srgbClr val="127584"/>
+                </a:solidFill>
+                <a:latin typeface="Hiragino Sans GB"/>
+              </a:rPr>
+              <a:t>扫码看个人主页</a:t>
+            </a:r>
+          </a:p>
+        </p:txBody>
+      </p:sp>
+      <p:sp>
+        <p:nvSpPr>
+          <p:cNvPr id="16" name="TextBox 15"/>
+          <p:cNvSpPr txBox="1"/>
+          <p:nvPr/>
+        </p:nvSpPr>
+        <p:spPr>
+          <a:xfrm>
+            <a:off x="9765792" y="5660136"/>
+            <a:ext cx="1691640" cy="182880"/>
+          </a:xfrm>
+          <a:prstGeom prst="rect">
+            <a:avLst/>
+          </a:prstGeom>
+          <a:noFill/>
+        </p:spPr>
+        <p:txBody>
+          <a:bodyPr wrap="square" lIns="18288" rIns="18288" tIns="9144" bIns="9144" anchor="t">
+            <a:spAutoFit/>
+          </a:bodyPr>
+          <a:lstStyle/>
+          <a:p>
+            <a:pPr algn="l">
+              <a:lnSpc>
+                <a:spcPct val="108000"/>
+              </a:lnSpc>
+            </a:pPr>
+            <a:r>
+              <a:rPr sz="900" b="1">
+                <a:solidFill>
+                  <a:srgbClr val="127584"/>
+                </a:solidFill>
+                <a:latin typeface="Aptos"/>
+              </a:rPr>
+              <a:t>hengqi61-maker.github.io</a:t>
+            </a:r>
+          </a:p>
+        </p:txBody>
+      </p:sp>
+      <p:sp>
+        <p:nvSpPr>
+          <p:cNvPr id="17" name="TextBox 16"/>
+          <p:cNvSpPr txBox="1"/>
+          <p:nvPr/>
+        </p:nvSpPr>
+        <p:spPr>
+          <a:xfrm>
+            <a:off x="9765792" y="5925312"/>
+            <a:ext cx="1627632" cy="201168"/>
+          </a:xfrm>
+          <a:prstGeom prst="rect">
+            <a:avLst/>
+          </a:prstGeom>
+          <a:noFill/>
+        </p:spPr>
+        <p:txBody>
+          <a:bodyPr wrap="square" lIns="18288" rIns="18288" tIns="9144" bIns="9144" anchor="t">
+            <a:spAutoFit/>
+          </a:bodyPr>
+          <a:lstStyle/>
+          <a:p>
+            <a:pPr algn="l">
+              <a:lnSpc>
+                <a:spcPct val="108000"/>
+              </a:lnSpc>
+            </a:pPr>
+            <a:r>
+              <a:rPr sz="850" b="0">
+                <a:solidFill>
+                  <a:srgbClr val="606C7A"/>
+                </a:solidFill>
+                <a:latin typeface="Hiragino Sans GB"/>
+              </a:rPr>
+              <a:t>项目入口 · 个人经历 · GitHub</a:t>
+            </a:r>
+          </a:p>
+        </p:txBody>
+      </p:sp>
+      <p:sp>
+        <p:nvSpPr>
+          <p:cNvPr id="18" name="Rectangle 17"/>
           <p:cNvSpPr/>
           <p:nvPr/>
         </p:nvSpPr>
@@ -3566,7 +3752,7 @@
       </p:sp>
       <p:sp>
         <p:nvSpPr>
-          <p:cNvPr id="14" name="TextBox 13"/>
+          <p:cNvPr id="19" name="TextBox 18"/>
           <p:cNvSpPr txBox="1"/>
           <p:nvPr/>
         </p:nvSpPr>
@@ -3605,7 +3791,7 @@
       </p:sp>
       <p:sp>
         <p:nvSpPr>
-          <p:cNvPr id="15" name="TextBox 14"/>
+          <p:cNvPr id="20" name="TextBox 19"/>
           <p:cNvSpPr txBox="1"/>
           <p:nvPr/>
         </p:nvSpPr>
@@ -3644,7 +3830,7 @@
       </p:sp>
       <p:sp>
         <p:nvSpPr>
-          <p:cNvPr id="16" name="TextBox 15"/>
+          <p:cNvPr id="21" name="TextBox 20"/>
           <p:cNvSpPr txBox="1"/>
           <p:nvPr/>
         </p:nvSpPr>
@@ -3683,7 +3869,7 @@
       </p:sp>
       <p:sp>
         <p:nvSpPr>
-          <p:cNvPr id="17" name="TextBox 16"/>
+          <p:cNvPr id="22" name="TextBox 21"/>
           <p:cNvSpPr txBox="1"/>
           <p:nvPr/>
         </p:nvSpPr>
@@ -3732,7 +3918,7 @@
       </p:sp>
       <p:sp>
         <p:nvSpPr>
-          <p:cNvPr id="18" name="TextBox 17"/>
+          <p:cNvPr id="23" name="TextBox 22"/>
           <p:cNvSpPr txBox="1"/>
           <p:nvPr/>
         </p:nvSpPr>
@@ -3771,7 +3957,7 @@
       </p:sp>
       <p:sp>
         <p:nvSpPr>
-          <p:cNvPr id="19" name="TextBox 18"/>
+          <p:cNvPr id="24" name="TextBox 23"/>
           <p:cNvSpPr txBox="1"/>
           <p:nvPr/>
         </p:nvSpPr>
@@ -3810,7 +3996,7 @@
       </p:sp>
       <p:sp>
         <p:nvSpPr>
-          <p:cNvPr id="20" name="TextBox 19"/>
+          <p:cNvPr id="25" name="TextBox 24"/>
           <p:cNvSpPr txBox="1"/>
           <p:nvPr/>
         </p:nvSpPr>
@@ -3836,7 +4022,7 @@
               </a:lnSpc>
             </a:pPr>
             <a:r>
-              <a:rPr sz="850" b="0">
+              <a:rPr sz="900" b="0">
                 <a:solidFill>
                   <a:srgbClr val="B8C9CE"/>
                 </a:solidFill>
@@ -4656,8 +4842,8 @@
         </p:nvSpPr>
         <p:spPr>
           <a:xfrm>
-            <a:off x="8942832" y="2368296"/>
-            <a:ext cx="768096" cy="146304"/>
+            <a:off x="8942832" y="2363724"/>
+            <a:ext cx="768096" cy="164592"/>
           </a:xfrm>
           <a:prstGeom prst="rect">
             <a:avLst/>
@@ -4676,7 +4862,7 @@
               </a:lnSpc>
             </a:pPr>
             <a:r>
-              <a:rPr sz="690" b="0">
+              <a:rPr sz="780" b="0">
                 <a:solidFill>
                   <a:srgbClr val="606C7A"/>
                 </a:solidFill>
@@ -4781,8 +4967,8 @@
         </p:nvSpPr>
         <p:spPr>
           <a:xfrm>
-            <a:off x="10780776" y="2354580"/>
-            <a:ext cx="219456" cy="146304"/>
+            <a:off x="10771632" y="2350008"/>
+            <a:ext cx="228600" cy="164592"/>
           </a:xfrm>
           <a:prstGeom prst="rect">
             <a:avLst/>
@@ -4801,7 +4987,7 @@
               </a:lnSpc>
             </a:pPr>
             <a:r>
-              <a:rPr sz="700" b="1">
+              <a:rPr sz="780" b="1">
                 <a:solidFill>
                   <a:srgbClr val="127584"/>
                 </a:solidFill>
@@ -4820,8 +5006,8 @@
         </p:nvSpPr>
         <p:spPr>
           <a:xfrm>
-            <a:off x="8942832" y="2615184"/>
-            <a:ext cx="768096" cy="146304"/>
+            <a:off x="8942832" y="2610612"/>
+            <a:ext cx="768096" cy="164592"/>
           </a:xfrm>
           <a:prstGeom prst="rect">
             <a:avLst/>
@@ -4840,7 +5026,7 @@
               </a:lnSpc>
             </a:pPr>
             <a:r>
-              <a:rPr sz="690" b="0">
+              <a:rPr sz="780" b="0">
                 <a:solidFill>
                   <a:srgbClr val="606C7A"/>
                 </a:solidFill>
@@ -4945,8 +5131,8 @@
         </p:nvSpPr>
         <p:spPr>
           <a:xfrm>
-            <a:off x="10780776" y="2601468"/>
-            <a:ext cx="219456" cy="146304"/>
+            <a:off x="10771632" y="2596896"/>
+            <a:ext cx="228600" cy="164592"/>
           </a:xfrm>
           <a:prstGeom prst="rect">
             <a:avLst/>
@@ -4965,7 +5151,7 @@
               </a:lnSpc>
             </a:pPr>
             <a:r>
-              <a:rPr sz="700" b="1">
+              <a:rPr sz="780" b="1">
                 <a:solidFill>
                   <a:srgbClr val="279789"/>
                 </a:solidFill>
@@ -4984,8 +5170,8 @@
         </p:nvSpPr>
         <p:spPr>
           <a:xfrm>
-            <a:off x="8942832" y="2862072"/>
-            <a:ext cx="768096" cy="146304"/>
+            <a:off x="8942832" y="2857500"/>
+            <a:ext cx="768096" cy="164592"/>
           </a:xfrm>
           <a:prstGeom prst="rect">
             <a:avLst/>
@@ -5004,7 +5190,7 @@
               </a:lnSpc>
             </a:pPr>
             <a:r>
-              <a:rPr sz="690" b="0">
+              <a:rPr sz="780" b="0">
                 <a:solidFill>
                   <a:srgbClr val="606C7A"/>
                 </a:solidFill>
@@ -5109,8 +5295,8 @@
         </p:nvSpPr>
         <p:spPr>
           <a:xfrm>
-            <a:off x="10780776" y="2848356"/>
-            <a:ext cx="219456" cy="146304"/>
+            <a:off x="10771632" y="2843784"/>
+            <a:ext cx="228600" cy="164592"/>
           </a:xfrm>
           <a:prstGeom prst="rect">
             <a:avLst/>
@@ -5129,7 +5315,7 @@
               </a:lnSpc>
             </a:pPr>
             <a:r>
-              <a:rPr sz="700" b="1">
+              <a:rPr sz="780" b="1">
                 <a:solidFill>
                   <a:srgbClr val="4F805E"/>
                 </a:solidFill>
@@ -5148,8 +5334,8 @@
         </p:nvSpPr>
         <p:spPr>
           <a:xfrm>
-            <a:off x="8942832" y="3108960"/>
-            <a:ext cx="768096" cy="146304"/>
+            <a:off x="8942832" y="3104388"/>
+            <a:ext cx="768096" cy="164592"/>
           </a:xfrm>
           <a:prstGeom prst="rect">
             <a:avLst/>
@@ -5168,7 +5354,7 @@
               </a:lnSpc>
             </a:pPr>
             <a:r>
-              <a:rPr sz="690" b="0">
+              <a:rPr sz="780" b="0">
                 <a:solidFill>
                   <a:srgbClr val="606C7A"/>
                 </a:solidFill>
@@ -5273,8 +5459,8 @@
         </p:nvSpPr>
         <p:spPr>
           <a:xfrm>
-            <a:off x="10780776" y="3095244"/>
-            <a:ext cx="219456" cy="146304"/>
+            <a:off x="10771632" y="3090672"/>
+            <a:ext cx="228600" cy="164592"/>
           </a:xfrm>
           <a:prstGeom prst="rect">
             <a:avLst/>
@@ -5293,7 +5479,7 @@
               </a:lnSpc>
             </a:pPr>
             <a:r>
-              <a:rPr sz="700" b="1">
+              <a:rPr sz="780" b="1">
                 <a:solidFill>
                   <a:srgbClr val="127584"/>
                 </a:solidFill>
@@ -5312,8 +5498,8 @@
         </p:nvSpPr>
         <p:spPr>
           <a:xfrm>
-            <a:off x="8942832" y="3355848"/>
-            <a:ext cx="768096" cy="146304"/>
+            <a:off x="8942832" y="3351276"/>
+            <a:ext cx="768096" cy="164592"/>
           </a:xfrm>
           <a:prstGeom prst="rect">
             <a:avLst/>
@@ -5332,7 +5518,7 @@
               </a:lnSpc>
             </a:pPr>
             <a:r>
-              <a:rPr sz="690" b="0">
+              <a:rPr sz="780" b="0">
                 <a:solidFill>
                   <a:srgbClr val="606C7A"/>
                 </a:solidFill>
@@ -5437,8 +5623,8 @@
         </p:nvSpPr>
         <p:spPr>
           <a:xfrm>
-            <a:off x="10780776" y="3342132"/>
-            <a:ext cx="219456" cy="146304"/>
+            <a:off x="10771632" y="3337560"/>
+            <a:ext cx="228600" cy="164592"/>
           </a:xfrm>
           <a:prstGeom prst="rect">
             <a:avLst/>
@@ -5457,7 +5643,7 @@
               </a:lnSpc>
             </a:pPr>
             <a:r>
-              <a:rPr sz="700" b="1">
+              <a:rPr sz="780" b="1">
                 <a:solidFill>
                   <a:srgbClr val="C48436"/>
                 </a:solidFill>
@@ -5476,8 +5662,8 @@
         </p:nvSpPr>
         <p:spPr>
           <a:xfrm>
-            <a:off x="8942832" y="3602736"/>
-            <a:ext cx="768096" cy="146304"/>
+            <a:off x="8942832" y="3598164"/>
+            <a:ext cx="768096" cy="164592"/>
           </a:xfrm>
           <a:prstGeom prst="rect">
             <a:avLst/>
@@ -5496,7 +5682,7 @@
               </a:lnSpc>
             </a:pPr>
             <a:r>
-              <a:rPr sz="690" b="0">
+              <a:rPr sz="780" b="0">
                 <a:solidFill>
                   <a:srgbClr val="606C7A"/>
                 </a:solidFill>
@@ -5601,8 +5787,8 @@
         </p:nvSpPr>
         <p:spPr>
           <a:xfrm>
-            <a:off x="10780776" y="3589020"/>
-            <a:ext cx="219456" cy="146304"/>
+            <a:off x="10771632" y="3584448"/>
+            <a:ext cx="228600" cy="164592"/>
           </a:xfrm>
           <a:prstGeom prst="rect">
             <a:avLst/>
@@ -5621,7 +5807,7 @@
               </a:lnSpc>
             </a:pPr>
             <a:r>
-              <a:rPr sz="700" b="1">
+              <a:rPr sz="780" b="1">
                 <a:solidFill>
                   <a:srgbClr val="665080"/>
                 </a:solidFill>
@@ -5640,8 +5826,8 @@
         </p:nvSpPr>
         <p:spPr>
           <a:xfrm>
-            <a:off x="8942832" y="3849624"/>
-            <a:ext cx="768096" cy="146304"/>
+            <a:off x="8942832" y="3845052"/>
+            <a:ext cx="768096" cy="164592"/>
           </a:xfrm>
           <a:prstGeom prst="rect">
             <a:avLst/>
@@ -5660,7 +5846,7 @@
               </a:lnSpc>
             </a:pPr>
             <a:r>
-              <a:rPr sz="690" b="0">
+              <a:rPr sz="780" b="0">
                 <a:solidFill>
                   <a:srgbClr val="606C7A"/>
                 </a:solidFill>
@@ -5765,8 +5951,8 @@
         </p:nvSpPr>
         <p:spPr>
           <a:xfrm>
-            <a:off x="10780776" y="3835908"/>
-            <a:ext cx="219456" cy="146304"/>
+            <a:off x="10771632" y="3831336"/>
+            <a:ext cx="228600" cy="164592"/>
           </a:xfrm>
           <a:prstGeom prst="rect">
             <a:avLst/>
@@ -5785,7 +5971,7 @@
               </a:lnSpc>
             </a:pPr>
             <a:r>
-              <a:rPr sz="700" b="1">
+              <a:rPr sz="780" b="1">
                 <a:solidFill>
                   <a:srgbClr val="2A3440"/>
                 </a:solidFill>
@@ -5804,8 +5990,8 @@
         </p:nvSpPr>
         <p:spPr>
           <a:xfrm>
-            <a:off x="8942832" y="4096511"/>
-            <a:ext cx="768096" cy="146304"/>
+            <a:off x="8942832" y="4091939"/>
+            <a:ext cx="768096" cy="164592"/>
           </a:xfrm>
           <a:prstGeom prst="rect">
             <a:avLst/>
@@ -5824,7 +6010,7 @@
               </a:lnSpc>
             </a:pPr>
             <a:r>
-              <a:rPr sz="690" b="0">
+              <a:rPr sz="780" b="0">
                 <a:solidFill>
                   <a:srgbClr val="606C7A"/>
                 </a:solidFill>
@@ -5929,8 +6115,8 @@
         </p:nvSpPr>
         <p:spPr>
           <a:xfrm>
-            <a:off x="10780776" y="4082796"/>
-            <a:ext cx="219456" cy="146304"/>
+            <a:off x="10771632" y="4078224"/>
+            <a:ext cx="228600" cy="164592"/>
           </a:xfrm>
           <a:prstGeom prst="rect">
             <a:avLst/>
@@ -5949,7 +6135,7 @@
               </a:lnSpc>
             </a:pPr>
             <a:r>
-              <a:rPr sz="700" b="1">
+              <a:rPr sz="780" b="1">
                 <a:solidFill>
                   <a:srgbClr val="4F805E"/>
                 </a:solidFill>
@@ -6134,8 +6320,8 @@
         </p:nvSpPr>
         <p:spPr>
           <a:xfrm>
-            <a:off x="1353312" y="4507992"/>
-            <a:ext cx="1481328" cy="402336"/>
+            <a:off x="1353312" y="4489704"/>
+            <a:ext cx="1481328" cy="438912"/>
           </a:xfrm>
           <a:prstGeom prst="rect">
             <a:avLst/>
@@ -6154,7 +6340,7 @@
               </a:lnSpc>
             </a:pPr>
             <a:r>
-              <a:rPr sz="810" b="0">
+              <a:rPr sz="900" b="0">
                 <a:solidFill>
                   <a:srgbClr val="606C7A"/>
                 </a:solidFill>
@@ -6339,8 +6525,8 @@
         </p:nvSpPr>
         <p:spPr>
           <a:xfrm>
-            <a:off x="4032504" y="4507992"/>
-            <a:ext cx="1481328" cy="402336"/>
+            <a:off x="4032504" y="4489704"/>
+            <a:ext cx="1481328" cy="438912"/>
           </a:xfrm>
           <a:prstGeom prst="rect">
             <a:avLst/>
@@ -6359,7 +6545,7 @@
               </a:lnSpc>
             </a:pPr>
             <a:r>
-              <a:rPr sz="810" b="0">
+              <a:rPr sz="900" b="0">
                 <a:solidFill>
                   <a:srgbClr val="606C7A"/>
                 </a:solidFill>
@@ -6544,8 +6730,8 @@
         </p:nvSpPr>
         <p:spPr>
           <a:xfrm>
-            <a:off x="6711696" y="4507992"/>
-            <a:ext cx="1481328" cy="402336"/>
+            <a:off x="6711696" y="4489704"/>
+            <a:ext cx="1481328" cy="438912"/>
           </a:xfrm>
           <a:prstGeom prst="rect">
             <a:avLst/>
@@ -6564,7 +6750,7 @@
               </a:lnSpc>
             </a:pPr>
             <a:r>
-              <a:rPr sz="810" b="0">
+              <a:rPr sz="900" b="0">
                 <a:solidFill>
                   <a:srgbClr val="606C7A"/>
                 </a:solidFill>
@@ -6657,8 +6843,8 @@
         </p:nvSpPr>
         <p:spPr>
           <a:xfrm>
-            <a:off x="566928" y="6501384"/>
-            <a:ext cx="5394960" cy="201168"/>
+            <a:off x="566928" y="6483096"/>
+            <a:ext cx="5394960" cy="219456"/>
           </a:xfrm>
           <a:prstGeom prst="rect">
             <a:avLst/>
@@ -6677,7 +6863,7 @@
               </a:lnSpc>
             </a:pPr>
             <a:r>
-              <a:rPr sz="750" b="0">
+              <a:rPr sz="840" b="0">
                 <a:solidFill>
                   <a:srgbClr val="606C7A"/>
                 </a:solidFill>
@@ -6696,8 +6882,8 @@
         </p:nvSpPr>
         <p:spPr>
           <a:xfrm>
-            <a:off x="5120640" y="6501384"/>
-            <a:ext cx="3566160" cy="201168"/>
+            <a:off x="5120640" y="6483096"/>
+            <a:ext cx="3566160" cy="219456"/>
           </a:xfrm>
           <a:prstGeom prst="rect">
             <a:avLst/>
@@ -6716,7 +6902,7 @@
               </a:lnSpc>
             </a:pPr>
             <a:r>
-              <a:rPr sz="750" b="0">
+              <a:rPr sz="840" b="0">
                 <a:solidFill>
                   <a:srgbClr val="7F8D9D"/>
                 </a:solidFill>
@@ -6735,8 +6921,8 @@
         </p:nvSpPr>
         <p:spPr>
           <a:xfrm>
-            <a:off x="11036808" y="6501384"/>
-            <a:ext cx="603504" cy="201168"/>
+            <a:off x="11036808" y="6483096"/>
+            <a:ext cx="603504" cy="219456"/>
           </a:xfrm>
           <a:prstGeom prst="rect">
             <a:avLst/>
@@ -6755,7 +6941,7 @@
               </a:lnSpc>
             </a:pPr>
             <a:r>
-              <a:rPr sz="750" b="0">
+              <a:rPr sz="840" b="0">
                 <a:solidFill>
                   <a:srgbClr val="606C7A"/>
                 </a:solidFill>
@@ -7199,7 +7385,7 @@
         <p:spPr>
           <a:xfrm>
             <a:off x="1143000" y="4032504"/>
-            <a:ext cx="1005840" cy="164592"/>
+            <a:ext cx="1005840" cy="182880"/>
           </a:xfrm>
           <a:prstGeom prst="rect">
             <a:avLst/>
@@ -7218,7 +7404,7 @@
               </a:lnSpc>
             </a:pPr>
             <a:r>
-              <a:rPr sz="880" b="1">
+              <a:rPr sz="1000" b="1">
                 <a:solidFill>
                   <a:srgbClr val="127584"/>
                 </a:solidFill>
@@ -7238,7 +7424,7 @@
         <p:spPr>
           <a:xfrm>
             <a:off x="1984248" y="4032504"/>
-            <a:ext cx="3474720" cy="182880"/>
+            <a:ext cx="3520440" cy="210312"/>
           </a:xfrm>
           <a:prstGeom prst="rect">
             <a:avLst/>
@@ -7257,7 +7443,7 @@
               </a:lnSpc>
             </a:pPr>
             <a:r>
-              <a:rPr sz="880" b="0">
+              <a:rPr sz="1000" b="0">
                 <a:solidFill>
                   <a:srgbClr val="606C7A"/>
                 </a:solidFill>
@@ -7320,7 +7506,7 @@
         <p:spPr>
           <a:xfrm>
             <a:off x="1143000" y="4352544"/>
-            <a:ext cx="1005840" cy="164592"/>
+            <a:ext cx="1005840" cy="182880"/>
           </a:xfrm>
           <a:prstGeom prst="rect">
             <a:avLst/>
@@ -7339,7 +7525,7 @@
               </a:lnSpc>
             </a:pPr>
             <a:r>
-              <a:rPr sz="880" b="1">
+              <a:rPr sz="1000" b="1">
                 <a:solidFill>
                   <a:srgbClr val="4F805E"/>
                 </a:solidFill>
@@ -7359,7 +7545,7 @@
         <p:spPr>
           <a:xfrm>
             <a:off x="1984248" y="4352544"/>
-            <a:ext cx="3474720" cy="182880"/>
+            <a:ext cx="3520440" cy="210312"/>
           </a:xfrm>
           <a:prstGeom prst="rect">
             <a:avLst/>
@@ -7378,7 +7564,7 @@
               </a:lnSpc>
             </a:pPr>
             <a:r>
-              <a:rPr sz="880" b="0">
+              <a:rPr sz="1000" b="0">
                 <a:solidFill>
                   <a:srgbClr val="606C7A"/>
                 </a:solidFill>
@@ -7441,7 +7627,7 @@
         <p:spPr>
           <a:xfrm>
             <a:off x="1143000" y="4672584"/>
-            <a:ext cx="1005840" cy="164592"/>
+            <a:ext cx="1005840" cy="182880"/>
           </a:xfrm>
           <a:prstGeom prst="rect">
             <a:avLst/>
@@ -7460,7 +7646,7 @@
               </a:lnSpc>
             </a:pPr>
             <a:r>
-              <a:rPr sz="880" b="1">
+              <a:rPr sz="1000" b="1">
                 <a:solidFill>
                   <a:srgbClr val="C48436"/>
                 </a:solidFill>
@@ -7480,7 +7666,7 @@
         <p:spPr>
           <a:xfrm>
             <a:off x="1984248" y="4672584"/>
-            <a:ext cx="3474720" cy="182880"/>
+            <a:ext cx="3520440" cy="210312"/>
           </a:xfrm>
           <a:prstGeom prst="rect">
             <a:avLst/>
@@ -7499,7 +7685,7 @@
               </a:lnSpc>
             </a:pPr>
             <a:r>
-              <a:rPr sz="880" b="0">
+              <a:rPr sz="1000" b="0">
                 <a:solidFill>
                   <a:srgbClr val="606C7A"/>
                 </a:solidFill>
@@ -7642,7 +7828,7 @@
         <p:spPr>
           <a:xfrm>
             <a:off x="6839712" y="3456432"/>
-            <a:ext cx="310896" cy="146304"/>
+            <a:ext cx="310896" cy="164592"/>
           </a:xfrm>
           <a:prstGeom prst="rect">
             <a:avLst/>
@@ -7661,7 +7847,7 @@
               </a:lnSpc>
             </a:pPr>
             <a:r>
-              <a:rPr sz="819" b="1">
+              <a:rPr sz="900" b="1">
                 <a:solidFill>
                   <a:srgbClr val="127584"/>
                 </a:solidFill>
@@ -7681,7 +7867,7 @@
         <p:spPr>
           <a:xfrm>
             <a:off x="7242048" y="3447288"/>
-            <a:ext cx="640080" cy="164592"/>
+            <a:ext cx="640080" cy="182880"/>
           </a:xfrm>
           <a:prstGeom prst="rect">
             <a:avLst/>
@@ -7700,7 +7886,7 @@
               </a:lnSpc>
             </a:pPr>
             <a:r>
-              <a:rPr sz="950" b="1">
+              <a:rPr sz="1019" b="1">
                 <a:solidFill>
                   <a:srgbClr val="121B27"/>
                 </a:solidFill>
@@ -7720,7 +7906,7 @@
         <p:spPr>
           <a:xfrm>
             <a:off x="7882127" y="3447288"/>
-            <a:ext cx="3154680" cy="228600"/>
+            <a:ext cx="3218688" cy="246888"/>
           </a:xfrm>
           <a:prstGeom prst="rect">
             <a:avLst/>
@@ -7739,7 +7925,7 @@
               </a:lnSpc>
             </a:pPr>
             <a:r>
-              <a:rPr sz="880" b="0">
+              <a:rPr sz="980" b="0">
                 <a:solidFill>
                   <a:srgbClr val="606C7A"/>
                 </a:solidFill>
@@ -7759,7 +7945,7 @@
         <p:spPr>
           <a:xfrm>
             <a:off x="6839712" y="3931920"/>
-            <a:ext cx="310896" cy="146304"/>
+            <a:ext cx="310896" cy="164592"/>
           </a:xfrm>
           <a:prstGeom prst="rect">
             <a:avLst/>
@@ -7778,7 +7964,7 @@
               </a:lnSpc>
             </a:pPr>
             <a:r>
-              <a:rPr sz="819" b="1">
+              <a:rPr sz="900" b="1">
                 <a:solidFill>
                   <a:srgbClr val="127584"/>
                 </a:solidFill>
@@ -7798,7 +7984,7 @@
         <p:spPr>
           <a:xfrm>
             <a:off x="7242048" y="3922776"/>
-            <a:ext cx="640080" cy="164592"/>
+            <a:ext cx="640080" cy="182880"/>
           </a:xfrm>
           <a:prstGeom prst="rect">
             <a:avLst/>
@@ -7817,7 +8003,7 @@
               </a:lnSpc>
             </a:pPr>
             <a:r>
-              <a:rPr sz="950" b="1">
+              <a:rPr sz="1019" b="1">
                 <a:solidFill>
                   <a:srgbClr val="121B27"/>
                 </a:solidFill>
@@ -7837,7 +8023,7 @@
         <p:spPr>
           <a:xfrm>
             <a:off x="7882127" y="3922776"/>
-            <a:ext cx="3154680" cy="228600"/>
+            <a:ext cx="3218688" cy="246888"/>
           </a:xfrm>
           <a:prstGeom prst="rect">
             <a:avLst/>
@@ -7856,7 +8042,7 @@
               </a:lnSpc>
             </a:pPr>
             <a:r>
-              <a:rPr sz="880" b="0">
+              <a:rPr sz="980" b="0">
                 <a:solidFill>
                   <a:srgbClr val="606C7A"/>
                 </a:solidFill>
@@ -7876,7 +8062,7 @@
         <p:spPr>
           <a:xfrm>
             <a:off x="6839712" y="4407408"/>
-            <a:ext cx="310896" cy="146304"/>
+            <a:ext cx="310896" cy="164592"/>
           </a:xfrm>
           <a:prstGeom prst="rect">
             <a:avLst/>
@@ -7895,7 +8081,7 @@
               </a:lnSpc>
             </a:pPr>
             <a:r>
-              <a:rPr sz="819" b="1">
+              <a:rPr sz="900" b="1">
                 <a:solidFill>
                   <a:srgbClr val="127584"/>
                 </a:solidFill>
@@ -7915,7 +8101,7 @@
         <p:spPr>
           <a:xfrm>
             <a:off x="7242048" y="4398264"/>
-            <a:ext cx="640080" cy="164592"/>
+            <a:ext cx="640080" cy="182880"/>
           </a:xfrm>
           <a:prstGeom prst="rect">
             <a:avLst/>
@@ -7934,7 +8120,7 @@
               </a:lnSpc>
             </a:pPr>
             <a:r>
-              <a:rPr sz="950" b="1">
+              <a:rPr sz="1019" b="1">
                 <a:solidFill>
                   <a:srgbClr val="121B27"/>
                 </a:solidFill>
@@ -7954,7 +8140,7 @@
         <p:spPr>
           <a:xfrm>
             <a:off x="7882127" y="4398264"/>
-            <a:ext cx="3154680" cy="228600"/>
+            <a:ext cx="3218688" cy="246888"/>
           </a:xfrm>
           <a:prstGeom prst="rect">
             <a:avLst/>
@@ -7973,7 +8159,7 @@
               </a:lnSpc>
             </a:pPr>
             <a:r>
-              <a:rPr sz="880" b="0">
+              <a:rPr sz="980" b="0">
                 <a:solidFill>
                   <a:srgbClr val="606C7A"/>
                 </a:solidFill>
@@ -8066,8 +8252,8 @@
         </p:nvSpPr>
         <p:spPr>
           <a:xfrm>
-            <a:off x="566928" y="6501384"/>
-            <a:ext cx="5394960" cy="201168"/>
+            <a:off x="566928" y="6483096"/>
+            <a:ext cx="5394960" cy="219456"/>
           </a:xfrm>
           <a:prstGeom prst="rect">
             <a:avLst/>
@@ -8086,7 +8272,7 @@
               </a:lnSpc>
             </a:pPr>
             <a:r>
-              <a:rPr sz="750" b="0">
+              <a:rPr sz="840" b="0">
                 <a:solidFill>
                   <a:srgbClr val="606C7A"/>
                 </a:solidFill>
@@ -8105,8 +8291,8 @@
         </p:nvSpPr>
         <p:spPr>
           <a:xfrm>
-            <a:off x="5120640" y="6501384"/>
-            <a:ext cx="3566160" cy="201168"/>
+            <a:off x="5120640" y="6483096"/>
+            <a:ext cx="3566160" cy="219456"/>
           </a:xfrm>
           <a:prstGeom prst="rect">
             <a:avLst/>
@@ -8125,7 +8311,7 @@
               </a:lnSpc>
             </a:pPr>
             <a:r>
-              <a:rPr sz="750" b="0">
+              <a:rPr sz="840" b="0">
                 <a:solidFill>
                   <a:srgbClr val="7F8D9D"/>
                 </a:solidFill>
@@ -8144,8 +8330,8 @@
         </p:nvSpPr>
         <p:spPr>
           <a:xfrm>
-            <a:off x="11036808" y="6501384"/>
-            <a:ext cx="603504" cy="201168"/>
+            <a:off x="11036808" y="6483096"/>
+            <a:ext cx="603504" cy="219456"/>
           </a:xfrm>
           <a:prstGeom prst="rect">
             <a:avLst/>
@@ -8164,7 +8350,7 @@
               </a:lnSpc>
             </a:pPr>
             <a:r>
-              <a:rPr sz="750" b="0">
+              <a:rPr sz="840" b="0">
                 <a:solidFill>
                   <a:srgbClr val="606C7A"/>
                 </a:solidFill>
@@ -8408,8 +8594,194 @@
         </p:nvSpPr>
         <p:spPr>
           <a:xfrm>
-            <a:off x="658368" y="1847088"/>
-            <a:ext cx="3401568" cy="3493008"/>
+            <a:off x="10808208" y="786384"/>
+            <a:ext cx="804672" cy="804672"/>
+          </a:xfrm>
+          <a:prstGeom prst="roundRect">
+            <a:avLst/>
+          </a:prstGeom>
+          <a:solidFill>
+            <a:srgbClr val="EFF7F8"/>
+          </a:solidFill>
+          <a:ln w="8890">
+            <a:solidFill>
+              <a:srgbClr val="C8DDE1"/>
+            </a:solidFill>
+          </a:ln>
+        </p:spPr>
+        <p:style>
+          <a:lnRef idx="1">
+            <a:schemeClr val="accent1"/>
+          </a:lnRef>
+          <a:fillRef idx="3">
+            <a:schemeClr val="accent1"/>
+          </a:fillRef>
+          <a:effectRef idx="2">
+            <a:schemeClr val="accent1"/>
+          </a:effectRef>
+          <a:fontRef idx="minor">
+            <a:schemeClr val="lt1"/>
+          </a:fontRef>
+        </p:style>
+        <p:txBody>
+          <a:bodyPr rtlCol="0" anchor="ctr"/>
+          <a:lstStyle/>
+          <a:p>
+            <a:pPr algn="ctr"/>
+          </a:p>
+        </p:txBody>
+      </p:sp>
+      <p:pic>
+        <p:nvPicPr>
+          <p:cNvPr id="8" name="Picture 7" descr="homepage_qr.png"/>
+          <p:cNvPicPr>
+            <a:picLocks noChangeAspect="1"/>
+          </p:cNvPicPr>
+          <p:nvPr/>
+        </p:nvPicPr>
+        <p:blipFill>
+          <a:blip r:embed="rId2"/>
+          <a:stretch>
+            <a:fillRect/>
+          </a:stretch>
+        </p:blipFill>
+        <p:spPr>
+          <a:xfrm>
+            <a:off x="10863072" y="841247"/>
+            <a:ext cx="694944" cy="694944"/>
+          </a:xfrm>
+          <a:prstGeom prst="rect">
+            <a:avLst/>
+          </a:prstGeom>
+        </p:spPr>
+      </p:pic>
+      <p:sp>
+        <p:nvSpPr>
+          <p:cNvPr id="9" name="TextBox 8"/>
+          <p:cNvSpPr txBox="1"/>
+          <p:nvPr/>
+        </p:nvSpPr>
+        <p:spPr>
+          <a:xfrm>
+            <a:off x="10716768" y="1645920"/>
+            <a:ext cx="1005840" cy="182880"/>
+          </a:xfrm>
+          <a:prstGeom prst="rect">
+            <a:avLst/>
+          </a:prstGeom>
+          <a:noFill/>
+        </p:spPr>
+        <p:txBody>
+          <a:bodyPr wrap="square" lIns="18288" rIns="18288" tIns="9144" bIns="9144" anchor="t">
+            <a:spAutoFit/>
+          </a:bodyPr>
+          <a:lstStyle/>
+          <a:p>
+            <a:pPr algn="ctr">
+              <a:lnSpc>
+                <a:spcPct val="108000"/>
+              </a:lnSpc>
+            </a:pPr>
+            <a:r>
+              <a:rPr sz="880" b="1">
+                <a:solidFill>
+                  <a:srgbClr val="127584"/>
+                </a:solidFill>
+                <a:latin typeface="Hiragino Sans GB"/>
+              </a:rPr>
+              <a:t>扫码看主页</a:t>
+            </a:r>
+          </a:p>
+        </p:txBody>
+      </p:sp>
+      <p:sp>
+        <p:nvSpPr>
+          <p:cNvPr id="10" name="TextBox 9"/>
+          <p:cNvSpPr txBox="1"/>
+          <p:nvPr/>
+        </p:nvSpPr>
+        <p:spPr>
+          <a:xfrm>
+            <a:off x="8796528" y="932688"/>
+            <a:ext cx="1737360" cy="182880"/>
+          </a:xfrm>
+          <a:prstGeom prst="rect">
+            <a:avLst/>
+          </a:prstGeom>
+          <a:noFill/>
+        </p:spPr>
+        <p:txBody>
+          <a:bodyPr wrap="square" lIns="18288" rIns="18288" tIns="9144" bIns="9144" anchor="t">
+            <a:spAutoFit/>
+          </a:bodyPr>
+          <a:lstStyle/>
+          <a:p>
+            <a:pPr algn="r">
+              <a:lnSpc>
+                <a:spcPct val="108000"/>
+              </a:lnSpc>
+            </a:pPr>
+            <a:r>
+              <a:rPr sz="1050" b="1">
+                <a:solidFill>
+                  <a:srgbClr val="127584"/>
+                </a:solidFill>
+                <a:latin typeface="Hiragino Sans GB"/>
+              </a:rPr>
+              <a:t>个人主页与 GitHub</a:t>
+            </a:r>
+          </a:p>
+        </p:txBody>
+      </p:sp>
+      <p:sp>
+        <p:nvSpPr>
+          <p:cNvPr id="11" name="TextBox 10"/>
+          <p:cNvSpPr txBox="1"/>
+          <p:nvPr/>
+        </p:nvSpPr>
+        <p:spPr>
+          <a:xfrm>
+            <a:off x="8668512" y="1207008"/>
+            <a:ext cx="1865376" cy="164592"/>
+          </a:xfrm>
+          <a:prstGeom prst="rect">
+            <a:avLst/>
+          </a:prstGeom>
+          <a:noFill/>
+        </p:spPr>
+        <p:txBody>
+          <a:bodyPr wrap="square" lIns="18288" rIns="18288" tIns="9144" bIns="9144" anchor="t">
+            <a:spAutoFit/>
+          </a:bodyPr>
+          <a:lstStyle/>
+          <a:p>
+            <a:pPr algn="r">
+              <a:lnSpc>
+                <a:spcPct val="108000"/>
+              </a:lnSpc>
+            </a:pPr>
+            <a:r>
+              <a:rPr sz="860" b="0">
+                <a:solidFill>
+                  <a:srgbClr val="606C7A"/>
+                </a:solidFill>
+                <a:latin typeface="Aptos"/>
+              </a:rPr>
+              <a:t>hengqi61-maker.github.io</a:t>
+            </a:r>
+          </a:p>
+        </p:txBody>
+      </p:sp>
+      <p:sp>
+        <p:nvSpPr>
+          <p:cNvPr id="12" name="Rounded Rectangle 11"/>
+          <p:cNvSpPr/>
+          <p:nvPr/>
+        </p:nvSpPr>
+        <p:spPr>
+          <a:xfrm>
+            <a:off x="658368" y="1828800"/>
+            <a:ext cx="3401568" cy="3566160"/>
           </a:xfrm>
           <a:prstGeom prst="roundRect">
             <a:avLst/>
@@ -8447,14 +8819,14 @@
       </p:sp>
       <p:sp>
         <p:nvSpPr>
-          <p:cNvPr id="8" name="TextBox 7"/>
-          <p:cNvSpPr txBox="1"/>
-          <p:nvPr/>
-        </p:nvSpPr>
-        <p:spPr>
-          <a:xfrm>
-            <a:off x="877824" y="2103120"/>
-            <a:ext cx="2194560" cy="164592"/>
+          <p:cNvPr id="13" name="TextBox 12"/>
+          <p:cNvSpPr txBox="1"/>
+          <p:nvPr/>
+        </p:nvSpPr>
+        <p:spPr>
+          <a:xfrm>
+            <a:off x="877824" y="2066543"/>
+            <a:ext cx="2194560" cy="182880"/>
           </a:xfrm>
           <a:prstGeom prst="rect">
             <a:avLst/>
@@ -8473,7 +8845,7 @@
               </a:lnSpc>
             </a:pPr>
             <a:r>
-              <a:rPr sz="720" b="1">
+              <a:rPr sz="819" b="1">
                 <a:solidFill>
                   <a:srgbClr val="127584"/>
                 </a:solidFill>
@@ -8486,14 +8858,14 @@
       </p:sp>
       <p:sp>
         <p:nvSpPr>
-          <p:cNvPr id="9" name="TextBox 8"/>
-          <p:cNvSpPr txBox="1"/>
-          <p:nvPr/>
-        </p:nvSpPr>
-        <p:spPr>
-          <a:xfrm>
-            <a:off x="877824" y="2395728"/>
-            <a:ext cx="2852928" cy="274320"/>
+          <p:cNvPr id="14" name="TextBox 13"/>
+          <p:cNvSpPr txBox="1"/>
+          <p:nvPr/>
+        </p:nvSpPr>
+        <p:spPr>
+          <a:xfrm>
+            <a:off x="877824" y="2368296"/>
+            <a:ext cx="2852928" cy="301752"/>
           </a:xfrm>
           <a:prstGeom prst="rect">
             <a:avLst/>
@@ -8512,7 +8884,7 @@
               </a:lnSpc>
             </a:pPr>
             <a:r>
-              <a:rPr sz="1360" b="1">
+              <a:rPr sz="1480" b="1">
                 <a:solidFill>
                   <a:srgbClr val="121B27"/>
                 </a:solidFill>
@@ -8525,14 +8897,14 @@
       </p:sp>
       <p:sp>
         <p:nvSpPr>
-          <p:cNvPr id="10" name="TextBox 9"/>
-          <p:cNvSpPr txBox="1"/>
-          <p:nvPr/>
-        </p:nvSpPr>
-        <p:spPr>
-          <a:xfrm>
-            <a:off x="896112" y="2880360"/>
-            <a:ext cx="658368" cy="164592"/>
+          <p:cNvPr id="15" name="TextBox 14"/>
+          <p:cNvSpPr txBox="1"/>
+          <p:nvPr/>
+        </p:nvSpPr>
+        <p:spPr>
+          <a:xfrm>
+            <a:off x="896112" y="2871216"/>
+            <a:ext cx="713232" cy="192024"/>
           </a:xfrm>
           <a:prstGeom prst="rect">
             <a:avLst/>
@@ -8551,7 +8923,7 @@
               </a:lnSpc>
             </a:pPr>
             <a:r>
-              <a:rPr sz="819" b="1">
+              <a:rPr sz="919" b="1">
                 <a:solidFill>
                   <a:srgbClr val="127584"/>
                 </a:solidFill>
@@ -8564,14 +8936,14 @@
       </p:sp>
       <p:sp>
         <p:nvSpPr>
-          <p:cNvPr id="11" name="TextBox 10"/>
-          <p:cNvSpPr txBox="1"/>
-          <p:nvPr/>
-        </p:nvSpPr>
-        <p:spPr>
-          <a:xfrm>
-            <a:off x="1554480" y="2871216"/>
-            <a:ext cx="2057400" cy="310896"/>
+          <p:cNvPr id="16" name="TextBox 15"/>
+          <p:cNvSpPr txBox="1"/>
+          <p:nvPr/>
+        </p:nvSpPr>
+        <p:spPr>
+          <a:xfrm>
+            <a:off x="1600200" y="2862072"/>
+            <a:ext cx="2139696" cy="374904"/>
           </a:xfrm>
           <a:prstGeom prst="rect">
             <a:avLst/>
@@ -8590,7 +8962,7 @@
               </a:lnSpc>
             </a:pPr>
             <a:r>
-              <a:rPr sz="810" b="0">
+              <a:rPr sz="960" b="0">
                 <a:solidFill>
                   <a:srgbClr val="606C7A"/>
                 </a:solidFill>
@@ -8603,14 +8975,14 @@
       </p:sp>
       <p:sp>
         <p:nvSpPr>
-          <p:cNvPr id="12" name="TextBox 11"/>
-          <p:cNvSpPr txBox="1"/>
-          <p:nvPr/>
-        </p:nvSpPr>
-        <p:spPr>
-          <a:xfrm>
-            <a:off x="896112" y="3538728"/>
-            <a:ext cx="658368" cy="164592"/>
+          <p:cNvPr id="17" name="TextBox 16"/>
+          <p:cNvSpPr txBox="1"/>
+          <p:nvPr/>
+        </p:nvSpPr>
+        <p:spPr>
+          <a:xfrm>
+            <a:off x="896112" y="3584448"/>
+            <a:ext cx="713232" cy="192024"/>
           </a:xfrm>
           <a:prstGeom prst="rect">
             <a:avLst/>
@@ -8629,7 +9001,7 @@
               </a:lnSpc>
             </a:pPr>
             <a:r>
-              <a:rPr sz="819" b="1">
+              <a:rPr sz="919" b="1">
                 <a:solidFill>
                   <a:srgbClr val="127584"/>
                 </a:solidFill>
@@ -8642,14 +9014,14 @@
       </p:sp>
       <p:sp>
         <p:nvSpPr>
-          <p:cNvPr id="13" name="TextBox 12"/>
-          <p:cNvSpPr txBox="1"/>
-          <p:nvPr/>
-        </p:nvSpPr>
-        <p:spPr>
-          <a:xfrm>
-            <a:off x="1554480" y="3529584"/>
-            <a:ext cx="2057400" cy="310896"/>
+          <p:cNvPr id="18" name="TextBox 17"/>
+          <p:cNvSpPr txBox="1"/>
+          <p:nvPr/>
+        </p:nvSpPr>
+        <p:spPr>
+          <a:xfrm>
+            <a:off x="1600200" y="3575304"/>
+            <a:ext cx="2139696" cy="374904"/>
           </a:xfrm>
           <a:prstGeom prst="rect">
             <a:avLst/>
@@ -8668,7 +9040,7 @@
               </a:lnSpc>
             </a:pPr>
             <a:r>
-              <a:rPr sz="810" b="0">
+              <a:rPr sz="960" b="0">
                 <a:solidFill>
                   <a:srgbClr val="606C7A"/>
                 </a:solidFill>
@@ -8681,14 +9053,14 @@
       </p:sp>
       <p:sp>
         <p:nvSpPr>
-          <p:cNvPr id="14" name="TextBox 13"/>
-          <p:cNvSpPr txBox="1"/>
-          <p:nvPr/>
-        </p:nvSpPr>
-        <p:spPr>
-          <a:xfrm>
-            <a:off x="896112" y="4197096"/>
-            <a:ext cx="658368" cy="164592"/>
+          <p:cNvPr id="19" name="TextBox 18"/>
+          <p:cNvSpPr txBox="1"/>
+          <p:nvPr/>
+        </p:nvSpPr>
+        <p:spPr>
+          <a:xfrm>
+            <a:off x="896112" y="4297680"/>
+            <a:ext cx="713232" cy="192024"/>
           </a:xfrm>
           <a:prstGeom prst="rect">
             <a:avLst/>
@@ -8707,7 +9079,7 @@
               </a:lnSpc>
             </a:pPr>
             <a:r>
-              <a:rPr sz="819" b="1">
+              <a:rPr sz="919" b="1">
                 <a:solidFill>
                   <a:srgbClr val="127584"/>
                 </a:solidFill>
@@ -8720,14 +9092,14 @@
       </p:sp>
       <p:sp>
         <p:nvSpPr>
-          <p:cNvPr id="15" name="TextBox 14"/>
-          <p:cNvSpPr txBox="1"/>
-          <p:nvPr/>
-        </p:nvSpPr>
-        <p:spPr>
-          <a:xfrm>
-            <a:off x="1554480" y="4187952"/>
-            <a:ext cx="2057400" cy="310896"/>
+          <p:cNvPr id="20" name="TextBox 19"/>
+          <p:cNvSpPr txBox="1"/>
+          <p:nvPr/>
+        </p:nvSpPr>
+        <p:spPr>
+          <a:xfrm>
+            <a:off x="1600200" y="4288536"/>
+            <a:ext cx="2139696" cy="374904"/>
           </a:xfrm>
           <a:prstGeom prst="rect">
             <a:avLst/>
@@ -8746,7 +9118,7 @@
               </a:lnSpc>
             </a:pPr>
             <a:r>
-              <a:rPr sz="810" b="0">
+              <a:rPr sz="960" b="0">
                 <a:solidFill>
                   <a:srgbClr val="606C7A"/>
                 </a:solidFill>
@@ -8759,14 +9131,14 @@
       </p:sp>
       <p:sp>
         <p:nvSpPr>
-          <p:cNvPr id="16" name="Rounded Rectangle 15"/>
+          <p:cNvPr id="21" name="Rounded Rectangle 20"/>
           <p:cNvSpPr/>
           <p:nvPr/>
         </p:nvSpPr>
         <p:spPr>
           <a:xfrm>
-            <a:off x="4462272" y="1847088"/>
-            <a:ext cx="3401568" cy="3493008"/>
+            <a:off x="4462272" y="1828800"/>
+            <a:ext cx="3401568" cy="3566160"/>
           </a:xfrm>
           <a:prstGeom prst="roundRect">
             <a:avLst/>
@@ -8804,14 +9176,14 @@
       </p:sp>
       <p:sp>
         <p:nvSpPr>
-          <p:cNvPr id="17" name="TextBox 16"/>
-          <p:cNvSpPr txBox="1"/>
-          <p:nvPr/>
-        </p:nvSpPr>
-        <p:spPr>
-          <a:xfrm>
-            <a:off x="4681728" y="2103120"/>
-            <a:ext cx="2194560" cy="164592"/>
+          <p:cNvPr id="22" name="TextBox 21"/>
+          <p:cNvSpPr txBox="1"/>
+          <p:nvPr/>
+        </p:nvSpPr>
+        <p:spPr>
+          <a:xfrm>
+            <a:off x="4681728" y="2066543"/>
+            <a:ext cx="2194560" cy="182880"/>
           </a:xfrm>
           <a:prstGeom prst="rect">
             <a:avLst/>
@@ -8830,7 +9202,7 @@
               </a:lnSpc>
             </a:pPr>
             <a:r>
-              <a:rPr sz="720" b="1">
+              <a:rPr sz="819" b="1">
                 <a:solidFill>
                   <a:srgbClr val="4F805E"/>
                 </a:solidFill>
@@ -8843,14 +9215,14 @@
       </p:sp>
       <p:sp>
         <p:nvSpPr>
-          <p:cNvPr id="18" name="TextBox 17"/>
-          <p:cNvSpPr txBox="1"/>
-          <p:nvPr/>
-        </p:nvSpPr>
-        <p:spPr>
-          <a:xfrm>
-            <a:off x="4681728" y="2395728"/>
-            <a:ext cx="2852928" cy="274320"/>
+          <p:cNvPr id="23" name="TextBox 22"/>
+          <p:cNvSpPr txBox="1"/>
+          <p:nvPr/>
+        </p:nvSpPr>
+        <p:spPr>
+          <a:xfrm>
+            <a:off x="4681728" y="2368296"/>
+            <a:ext cx="2852928" cy="301752"/>
           </a:xfrm>
           <a:prstGeom prst="rect">
             <a:avLst/>
@@ -8869,7 +9241,7 @@
               </a:lnSpc>
             </a:pPr>
             <a:r>
-              <a:rPr sz="1360" b="1">
+              <a:rPr sz="1480" b="1">
                 <a:solidFill>
                   <a:srgbClr val="121B27"/>
                 </a:solidFill>
@@ -8882,14 +9254,14 @@
       </p:sp>
       <p:sp>
         <p:nvSpPr>
-          <p:cNvPr id="19" name="TextBox 18"/>
-          <p:cNvSpPr txBox="1"/>
-          <p:nvPr/>
-        </p:nvSpPr>
-        <p:spPr>
-          <a:xfrm>
-            <a:off x="4700016" y="2880360"/>
-            <a:ext cx="658368" cy="164592"/>
+          <p:cNvPr id="24" name="TextBox 23"/>
+          <p:cNvSpPr txBox="1"/>
+          <p:nvPr/>
+        </p:nvSpPr>
+        <p:spPr>
+          <a:xfrm>
+            <a:off x="4700016" y="2871216"/>
+            <a:ext cx="713232" cy="192024"/>
           </a:xfrm>
           <a:prstGeom prst="rect">
             <a:avLst/>
@@ -8908,7 +9280,7 @@
               </a:lnSpc>
             </a:pPr>
             <a:r>
-              <a:rPr sz="819" b="1">
+              <a:rPr sz="919" b="1">
                 <a:solidFill>
                   <a:srgbClr val="4F805E"/>
                 </a:solidFill>
@@ -8921,14 +9293,14 @@
       </p:sp>
       <p:sp>
         <p:nvSpPr>
-          <p:cNvPr id="20" name="TextBox 19"/>
-          <p:cNvSpPr txBox="1"/>
-          <p:nvPr/>
-        </p:nvSpPr>
-        <p:spPr>
-          <a:xfrm>
-            <a:off x="5358383" y="2871216"/>
-            <a:ext cx="2057400" cy="310896"/>
+          <p:cNvPr id="25" name="TextBox 24"/>
+          <p:cNvSpPr txBox="1"/>
+          <p:nvPr/>
+        </p:nvSpPr>
+        <p:spPr>
+          <a:xfrm>
+            <a:off x="5404104" y="2862072"/>
+            <a:ext cx="2139696" cy="374904"/>
           </a:xfrm>
           <a:prstGeom prst="rect">
             <a:avLst/>
@@ -8947,7 +9319,7 @@
               </a:lnSpc>
             </a:pPr>
             <a:r>
-              <a:rPr sz="810" b="0">
+              <a:rPr sz="960" b="0">
                 <a:solidFill>
                   <a:srgbClr val="606C7A"/>
                 </a:solidFill>
@@ -8960,14 +9332,14 @@
       </p:sp>
       <p:sp>
         <p:nvSpPr>
-          <p:cNvPr id="21" name="TextBox 20"/>
-          <p:cNvSpPr txBox="1"/>
-          <p:nvPr/>
-        </p:nvSpPr>
-        <p:spPr>
-          <a:xfrm>
-            <a:off x="4700016" y="3538728"/>
-            <a:ext cx="658368" cy="164592"/>
+          <p:cNvPr id="26" name="TextBox 25"/>
+          <p:cNvSpPr txBox="1"/>
+          <p:nvPr/>
+        </p:nvSpPr>
+        <p:spPr>
+          <a:xfrm>
+            <a:off x="4700016" y="3584448"/>
+            <a:ext cx="713232" cy="192024"/>
           </a:xfrm>
           <a:prstGeom prst="rect">
             <a:avLst/>
@@ -8986,7 +9358,7 @@
               </a:lnSpc>
             </a:pPr>
             <a:r>
-              <a:rPr sz="819" b="1">
+              <a:rPr sz="919" b="1">
                 <a:solidFill>
                   <a:srgbClr val="4F805E"/>
                 </a:solidFill>
@@ -8999,14 +9371,14 @@
       </p:sp>
       <p:sp>
         <p:nvSpPr>
-          <p:cNvPr id="22" name="TextBox 21"/>
-          <p:cNvSpPr txBox="1"/>
-          <p:nvPr/>
-        </p:nvSpPr>
-        <p:spPr>
-          <a:xfrm>
-            <a:off x="5358383" y="3529584"/>
-            <a:ext cx="2057400" cy="310896"/>
+          <p:cNvPr id="27" name="TextBox 26"/>
+          <p:cNvSpPr txBox="1"/>
+          <p:nvPr/>
+        </p:nvSpPr>
+        <p:spPr>
+          <a:xfrm>
+            <a:off x="5404104" y="3575304"/>
+            <a:ext cx="2139696" cy="374904"/>
           </a:xfrm>
           <a:prstGeom prst="rect">
             <a:avLst/>
@@ -9025,7 +9397,7 @@
               </a:lnSpc>
             </a:pPr>
             <a:r>
-              <a:rPr sz="810" b="0">
+              <a:rPr sz="960" b="0">
                 <a:solidFill>
                   <a:srgbClr val="606C7A"/>
                 </a:solidFill>
@@ -9038,14 +9410,14 @@
       </p:sp>
       <p:sp>
         <p:nvSpPr>
-          <p:cNvPr id="23" name="TextBox 22"/>
-          <p:cNvSpPr txBox="1"/>
-          <p:nvPr/>
-        </p:nvSpPr>
-        <p:spPr>
-          <a:xfrm>
-            <a:off x="4700016" y="4197096"/>
-            <a:ext cx="658368" cy="164592"/>
+          <p:cNvPr id="28" name="TextBox 27"/>
+          <p:cNvSpPr txBox="1"/>
+          <p:nvPr/>
+        </p:nvSpPr>
+        <p:spPr>
+          <a:xfrm>
+            <a:off x="4700016" y="4297680"/>
+            <a:ext cx="713232" cy="192024"/>
           </a:xfrm>
           <a:prstGeom prst="rect">
             <a:avLst/>
@@ -9064,7 +9436,7 @@
               </a:lnSpc>
             </a:pPr>
             <a:r>
-              <a:rPr sz="819" b="1">
+              <a:rPr sz="919" b="1">
                 <a:solidFill>
                   <a:srgbClr val="4F805E"/>
                 </a:solidFill>
@@ -9077,14 +9449,14 @@
       </p:sp>
       <p:sp>
         <p:nvSpPr>
-          <p:cNvPr id="24" name="TextBox 23"/>
-          <p:cNvSpPr txBox="1"/>
-          <p:nvPr/>
-        </p:nvSpPr>
-        <p:spPr>
-          <a:xfrm>
-            <a:off x="5358383" y="4187952"/>
-            <a:ext cx="2057400" cy="310896"/>
+          <p:cNvPr id="29" name="TextBox 28"/>
+          <p:cNvSpPr txBox="1"/>
+          <p:nvPr/>
+        </p:nvSpPr>
+        <p:spPr>
+          <a:xfrm>
+            <a:off x="5404104" y="4288536"/>
+            <a:ext cx="2139696" cy="374904"/>
           </a:xfrm>
           <a:prstGeom prst="rect">
             <a:avLst/>
@@ -9103,7 +9475,7 @@
               </a:lnSpc>
             </a:pPr>
             <a:r>
-              <a:rPr sz="810" b="0">
+              <a:rPr sz="960" b="0">
                 <a:solidFill>
                   <a:srgbClr val="606C7A"/>
                 </a:solidFill>
@@ -9116,14 +9488,14 @@
       </p:sp>
       <p:sp>
         <p:nvSpPr>
-          <p:cNvPr id="25" name="Rounded Rectangle 24"/>
+          <p:cNvPr id="30" name="Rounded Rectangle 29"/>
           <p:cNvSpPr/>
           <p:nvPr/>
         </p:nvSpPr>
         <p:spPr>
           <a:xfrm>
-            <a:off x="8266176" y="1847088"/>
-            <a:ext cx="3401568" cy="3493008"/>
+            <a:off x="8266176" y="1828800"/>
+            <a:ext cx="3401568" cy="3566160"/>
           </a:xfrm>
           <a:prstGeom prst="roundRect">
             <a:avLst/>
@@ -9161,14 +9533,14 @@
       </p:sp>
       <p:sp>
         <p:nvSpPr>
-          <p:cNvPr id="26" name="TextBox 25"/>
-          <p:cNvSpPr txBox="1"/>
-          <p:nvPr/>
-        </p:nvSpPr>
-        <p:spPr>
-          <a:xfrm>
-            <a:off x="8485632" y="2103120"/>
-            <a:ext cx="2194560" cy="164592"/>
+          <p:cNvPr id="31" name="TextBox 30"/>
+          <p:cNvSpPr txBox="1"/>
+          <p:nvPr/>
+        </p:nvSpPr>
+        <p:spPr>
+          <a:xfrm>
+            <a:off x="8485632" y="2066543"/>
+            <a:ext cx="2194560" cy="182880"/>
           </a:xfrm>
           <a:prstGeom prst="rect">
             <a:avLst/>
@@ -9187,7 +9559,7 @@
               </a:lnSpc>
             </a:pPr>
             <a:r>
-              <a:rPr sz="720" b="1">
+              <a:rPr sz="819" b="1">
                 <a:solidFill>
                   <a:srgbClr val="665080"/>
                 </a:solidFill>
@@ -9200,14 +9572,14 @@
       </p:sp>
       <p:sp>
         <p:nvSpPr>
-          <p:cNvPr id="27" name="TextBox 26"/>
-          <p:cNvSpPr txBox="1"/>
-          <p:nvPr/>
-        </p:nvSpPr>
-        <p:spPr>
-          <a:xfrm>
-            <a:off x="8485632" y="2395728"/>
-            <a:ext cx="2852928" cy="274320"/>
+          <p:cNvPr id="32" name="TextBox 31"/>
+          <p:cNvSpPr txBox="1"/>
+          <p:nvPr/>
+        </p:nvSpPr>
+        <p:spPr>
+          <a:xfrm>
+            <a:off x="8485632" y="2368296"/>
+            <a:ext cx="2852928" cy="301752"/>
           </a:xfrm>
           <a:prstGeom prst="rect">
             <a:avLst/>
@@ -9226,7 +9598,7 @@
               </a:lnSpc>
             </a:pPr>
             <a:r>
-              <a:rPr sz="1360" b="1">
+              <a:rPr sz="1480" b="1">
                 <a:solidFill>
                   <a:srgbClr val="121B27"/>
                 </a:solidFill>
@@ -9239,14 +9611,14 @@
       </p:sp>
       <p:sp>
         <p:nvSpPr>
-          <p:cNvPr id="28" name="TextBox 27"/>
-          <p:cNvSpPr txBox="1"/>
-          <p:nvPr/>
-        </p:nvSpPr>
-        <p:spPr>
-          <a:xfrm>
-            <a:off x="8503920" y="2880360"/>
-            <a:ext cx="658368" cy="164592"/>
+          <p:cNvPr id="33" name="TextBox 32"/>
+          <p:cNvSpPr txBox="1"/>
+          <p:nvPr/>
+        </p:nvSpPr>
+        <p:spPr>
+          <a:xfrm>
+            <a:off x="8503920" y="2871216"/>
+            <a:ext cx="713232" cy="192024"/>
           </a:xfrm>
           <a:prstGeom prst="rect">
             <a:avLst/>
@@ -9265,7 +9637,7 @@
               </a:lnSpc>
             </a:pPr>
             <a:r>
-              <a:rPr sz="819" b="1">
+              <a:rPr sz="919" b="1">
                 <a:solidFill>
                   <a:srgbClr val="665080"/>
                 </a:solidFill>
@@ -9278,14 +9650,14 @@
       </p:sp>
       <p:sp>
         <p:nvSpPr>
-          <p:cNvPr id="29" name="TextBox 28"/>
-          <p:cNvSpPr txBox="1"/>
-          <p:nvPr/>
-        </p:nvSpPr>
-        <p:spPr>
-          <a:xfrm>
-            <a:off x="9162288" y="2871216"/>
-            <a:ext cx="2057400" cy="310896"/>
+          <p:cNvPr id="34" name="TextBox 33"/>
+          <p:cNvSpPr txBox="1"/>
+          <p:nvPr/>
+        </p:nvSpPr>
+        <p:spPr>
+          <a:xfrm>
+            <a:off x="9208008" y="2862072"/>
+            <a:ext cx="2139696" cy="374904"/>
           </a:xfrm>
           <a:prstGeom prst="rect">
             <a:avLst/>
@@ -9304,7 +9676,7 @@
               </a:lnSpc>
             </a:pPr>
             <a:r>
-              <a:rPr sz="810" b="0">
+              <a:rPr sz="960" b="0">
                 <a:solidFill>
                   <a:srgbClr val="606C7A"/>
                 </a:solidFill>
@@ -9317,14 +9689,14 @@
       </p:sp>
       <p:sp>
         <p:nvSpPr>
-          <p:cNvPr id="30" name="TextBox 29"/>
-          <p:cNvSpPr txBox="1"/>
-          <p:nvPr/>
-        </p:nvSpPr>
-        <p:spPr>
-          <a:xfrm>
-            <a:off x="8503920" y="3538728"/>
-            <a:ext cx="658368" cy="164592"/>
+          <p:cNvPr id="35" name="TextBox 34"/>
+          <p:cNvSpPr txBox="1"/>
+          <p:nvPr/>
+        </p:nvSpPr>
+        <p:spPr>
+          <a:xfrm>
+            <a:off x="8503920" y="3584448"/>
+            <a:ext cx="713232" cy="192024"/>
           </a:xfrm>
           <a:prstGeom prst="rect">
             <a:avLst/>
@@ -9343,7 +9715,7 @@
               </a:lnSpc>
             </a:pPr>
             <a:r>
-              <a:rPr sz="819" b="1">
+              <a:rPr sz="919" b="1">
                 <a:solidFill>
                   <a:srgbClr val="665080"/>
                 </a:solidFill>
@@ -9356,14 +9728,14 @@
       </p:sp>
       <p:sp>
         <p:nvSpPr>
-          <p:cNvPr id="31" name="TextBox 30"/>
-          <p:cNvSpPr txBox="1"/>
-          <p:nvPr/>
-        </p:nvSpPr>
-        <p:spPr>
-          <a:xfrm>
-            <a:off x="9162288" y="3529584"/>
-            <a:ext cx="2057400" cy="310896"/>
+          <p:cNvPr id="36" name="TextBox 35"/>
+          <p:cNvSpPr txBox="1"/>
+          <p:nvPr/>
+        </p:nvSpPr>
+        <p:spPr>
+          <a:xfrm>
+            <a:off x="9208008" y="3575304"/>
+            <a:ext cx="2139696" cy="374904"/>
           </a:xfrm>
           <a:prstGeom prst="rect">
             <a:avLst/>
@@ -9382,7 +9754,7 @@
               </a:lnSpc>
             </a:pPr>
             <a:r>
-              <a:rPr sz="810" b="0">
+              <a:rPr sz="960" b="0">
                 <a:solidFill>
                   <a:srgbClr val="606C7A"/>
                 </a:solidFill>
@@ -9395,14 +9767,14 @@
       </p:sp>
       <p:sp>
         <p:nvSpPr>
-          <p:cNvPr id="32" name="TextBox 31"/>
-          <p:cNvSpPr txBox="1"/>
-          <p:nvPr/>
-        </p:nvSpPr>
-        <p:spPr>
-          <a:xfrm>
-            <a:off x="8503920" y="4197096"/>
-            <a:ext cx="658368" cy="164592"/>
+          <p:cNvPr id="37" name="TextBox 36"/>
+          <p:cNvSpPr txBox="1"/>
+          <p:nvPr/>
+        </p:nvSpPr>
+        <p:spPr>
+          <a:xfrm>
+            <a:off x="8503920" y="4297680"/>
+            <a:ext cx="713232" cy="192024"/>
           </a:xfrm>
           <a:prstGeom prst="rect">
             <a:avLst/>
@@ -9421,7 +9793,7 @@
               </a:lnSpc>
             </a:pPr>
             <a:r>
-              <a:rPr sz="819" b="1">
+              <a:rPr sz="919" b="1">
                 <a:solidFill>
                   <a:srgbClr val="665080"/>
                 </a:solidFill>
@@ -9434,14 +9806,14 @@
       </p:sp>
       <p:sp>
         <p:nvSpPr>
-          <p:cNvPr id="33" name="TextBox 32"/>
-          <p:cNvSpPr txBox="1"/>
-          <p:nvPr/>
-        </p:nvSpPr>
-        <p:spPr>
-          <a:xfrm>
-            <a:off x="9162288" y="4187952"/>
-            <a:ext cx="2057400" cy="310896"/>
+          <p:cNvPr id="38" name="TextBox 37"/>
+          <p:cNvSpPr txBox="1"/>
+          <p:nvPr/>
+        </p:nvSpPr>
+        <p:spPr>
+          <a:xfrm>
+            <a:off x="9208008" y="4288536"/>
+            <a:ext cx="2139696" cy="374904"/>
           </a:xfrm>
           <a:prstGeom prst="rect">
             <a:avLst/>
@@ -9460,7 +9832,7 @@
               </a:lnSpc>
             </a:pPr>
             <a:r>
-              <a:rPr sz="810" b="0">
+              <a:rPr sz="960" b="0">
                 <a:solidFill>
                   <a:srgbClr val="606C7A"/>
                 </a:solidFill>
@@ -9473,14 +9845,14 @@
       </p:sp>
       <p:sp>
         <p:nvSpPr>
-          <p:cNvPr id="34" name="Rounded Rectangle 33"/>
+          <p:cNvPr id="39" name="Rounded Rectangle 38"/>
           <p:cNvSpPr/>
           <p:nvPr/>
         </p:nvSpPr>
         <p:spPr>
           <a:xfrm>
-            <a:off x="822960" y="5596128"/>
-            <a:ext cx="10561320" cy="384048"/>
+            <a:off x="822960" y="5605272"/>
+            <a:ext cx="10561320" cy="393192"/>
           </a:xfrm>
           <a:prstGeom prst="roundRect">
             <a:avLst/>
@@ -9518,14 +9890,14 @@
       </p:sp>
       <p:sp>
         <p:nvSpPr>
-          <p:cNvPr id="35" name="TextBox 34"/>
+          <p:cNvPr id="40" name="TextBox 39"/>
           <p:cNvSpPr txBox="1"/>
           <p:nvPr/>
         </p:nvSpPr>
         <p:spPr>
           <a:xfrm>
             <a:off x="1024128" y="5715000"/>
-            <a:ext cx="10104120" cy="155448"/>
+            <a:ext cx="10104120" cy="164592"/>
           </a:xfrm>
           <a:prstGeom prst="rect">
             <a:avLst/>
@@ -9544,20 +9916,20 @@
               </a:lnSpc>
             </a:pPr>
             <a:r>
-              <a:rPr sz="1180" b="1">
+              <a:rPr sz="1260" b="1">
                 <a:solidFill>
                   <a:srgbClr val="127584"/>
                 </a:solidFill>
                 <a:latin typeface="Hiragino Sans GB"/>
               </a:rPr>
-              <a:t>这三类项目共同证明：我不是等任务分配，而是会主动找问题、做原型、验证和迭代。</a:t>
+              <a:t>共同证明：我会主动找问题、做原型、验证和迭代。更多项目证据可扫码查看个人主页。</a:t>
             </a:r>
           </a:p>
         </p:txBody>
       </p:sp>
       <p:cxnSp>
         <p:nvCxnSpPr>
-          <p:cNvPr id="36" name="Connector 35"/>
+          <p:cNvPr id="41" name="Connector 40"/>
           <p:cNvCxnSpPr/>
           <p:nvPr/>
         </p:nvCxnSpPr>
@@ -9592,14 +9964,14 @@
       </p:cxnSp>
       <p:sp>
         <p:nvSpPr>
-          <p:cNvPr id="37" name="TextBox 36"/>
-          <p:cNvSpPr txBox="1"/>
-          <p:nvPr/>
-        </p:nvSpPr>
-        <p:spPr>
-          <a:xfrm>
-            <a:off x="566928" y="6501384"/>
-            <a:ext cx="5394960" cy="201168"/>
+          <p:cNvPr id="42" name="TextBox 41"/>
+          <p:cNvSpPr txBox="1"/>
+          <p:nvPr/>
+        </p:nvSpPr>
+        <p:spPr>
+          <a:xfrm>
+            <a:off x="566928" y="6483096"/>
+            <a:ext cx="5394960" cy="219456"/>
           </a:xfrm>
           <a:prstGeom prst="rect">
             <a:avLst/>
@@ -9618,7 +9990,7 @@
               </a:lnSpc>
             </a:pPr>
             <a:r>
-              <a:rPr sz="750" b="0">
+              <a:rPr sz="840" b="0">
                 <a:solidFill>
                   <a:srgbClr val="606C7A"/>
                 </a:solidFill>
@@ -9631,14 +10003,14 @@
       </p:sp>
       <p:sp>
         <p:nvSpPr>
-          <p:cNvPr id="38" name="TextBox 37"/>
-          <p:cNvSpPr txBox="1"/>
-          <p:nvPr/>
-        </p:nvSpPr>
-        <p:spPr>
-          <a:xfrm>
-            <a:off x="5120640" y="6501384"/>
-            <a:ext cx="3566160" cy="201168"/>
+          <p:cNvPr id="43" name="TextBox 42"/>
+          <p:cNvSpPr txBox="1"/>
+          <p:nvPr/>
+        </p:nvSpPr>
+        <p:spPr>
+          <a:xfrm>
+            <a:off x="5120640" y="6483096"/>
+            <a:ext cx="3566160" cy="219456"/>
           </a:xfrm>
           <a:prstGeom prst="rect">
             <a:avLst/>
@@ -9657,7 +10029,7 @@
               </a:lnSpc>
             </a:pPr>
             <a:r>
-              <a:rPr sz="750" b="0">
+              <a:rPr sz="840" b="0">
                 <a:solidFill>
                   <a:srgbClr val="7F8D9D"/>
                 </a:solidFill>
@@ -9670,14 +10042,14 @@
       </p:sp>
       <p:sp>
         <p:nvSpPr>
-          <p:cNvPr id="39" name="TextBox 38"/>
-          <p:cNvSpPr txBox="1"/>
-          <p:nvPr/>
-        </p:nvSpPr>
-        <p:spPr>
-          <a:xfrm>
-            <a:off x="11036808" y="6501384"/>
-            <a:ext cx="603504" cy="201168"/>
+          <p:cNvPr id="44" name="TextBox 43"/>
+          <p:cNvSpPr txBox="1"/>
+          <p:nvPr/>
+        </p:nvSpPr>
+        <p:spPr>
+          <a:xfrm>
+            <a:off x="11036808" y="6483096"/>
+            <a:ext cx="603504" cy="219456"/>
           </a:xfrm>
           <a:prstGeom prst="rect">
             <a:avLst/>
@@ -9696,7 +10068,7 @@
               </a:lnSpc>
             </a:pPr>
             <a:r>
-              <a:rPr sz="750" b="0">
+              <a:rPr sz="840" b="0">
                 <a:solidFill>
                   <a:srgbClr val="606C7A"/>
                 </a:solidFill>
@@ -10604,8 +10976,8 @@
         </p:nvSpPr>
         <p:spPr>
           <a:xfrm>
-            <a:off x="5779008" y="2441448"/>
-            <a:ext cx="1783080" cy="384048"/>
+            <a:off x="5779008" y="2432303"/>
+            <a:ext cx="1847088" cy="420624"/>
           </a:xfrm>
           <a:prstGeom prst="rect">
             <a:avLst/>
@@ -10624,7 +10996,7 @@
               </a:lnSpc>
             </a:pPr>
             <a:r>
-              <a:rPr sz="880" b="0">
+              <a:rPr sz="960" b="0">
                 <a:solidFill>
                   <a:srgbClr val="606C7A"/>
                 </a:solidFill>
@@ -10809,8 +11181,8 @@
         </p:nvSpPr>
         <p:spPr>
           <a:xfrm>
-            <a:off x="8915400" y="2441448"/>
-            <a:ext cx="1783080" cy="384048"/>
+            <a:off x="8915400" y="2432303"/>
+            <a:ext cx="1847088" cy="420624"/>
           </a:xfrm>
           <a:prstGeom prst="rect">
             <a:avLst/>
@@ -10829,7 +11201,7 @@
               </a:lnSpc>
             </a:pPr>
             <a:r>
-              <a:rPr sz="880" b="0">
+              <a:rPr sz="960" b="0">
                 <a:solidFill>
                   <a:srgbClr val="606C7A"/>
                 </a:solidFill>
@@ -11014,8 +11386,8 @@
         </p:nvSpPr>
         <p:spPr>
           <a:xfrm>
-            <a:off x="5779008" y="4014215"/>
-            <a:ext cx="1783080" cy="384048"/>
+            <a:off x="5779008" y="4005072"/>
+            <a:ext cx="1847088" cy="420624"/>
           </a:xfrm>
           <a:prstGeom prst="rect">
             <a:avLst/>
@@ -11034,7 +11406,7 @@
               </a:lnSpc>
             </a:pPr>
             <a:r>
-              <a:rPr sz="880" b="0">
+              <a:rPr sz="960" b="0">
                 <a:solidFill>
                   <a:srgbClr val="606C7A"/>
                 </a:solidFill>
@@ -11219,8 +11591,8 @@
         </p:nvSpPr>
         <p:spPr>
           <a:xfrm>
-            <a:off x="8915400" y="4014215"/>
-            <a:ext cx="1783080" cy="384048"/>
+            <a:off x="8915400" y="4005072"/>
+            <a:ext cx="1847088" cy="420624"/>
           </a:xfrm>
           <a:prstGeom prst="rect">
             <a:avLst/>
@@ -11239,7 +11611,7 @@
               </a:lnSpc>
             </a:pPr>
             <a:r>
-              <a:rPr sz="880" b="0">
+              <a:rPr sz="960" b="0">
                 <a:solidFill>
                   <a:srgbClr val="606C7A"/>
                 </a:solidFill>
@@ -11332,8 +11704,8 @@
         </p:nvSpPr>
         <p:spPr>
           <a:xfrm>
-            <a:off x="566928" y="6501384"/>
-            <a:ext cx="5394960" cy="201168"/>
+            <a:off x="566928" y="6483096"/>
+            <a:ext cx="5394960" cy="219456"/>
           </a:xfrm>
           <a:prstGeom prst="rect">
             <a:avLst/>
@@ -11352,7 +11724,7 @@
               </a:lnSpc>
             </a:pPr>
             <a:r>
-              <a:rPr sz="750" b="0">
+              <a:rPr sz="840" b="0">
                 <a:solidFill>
                   <a:srgbClr val="606C7A"/>
                 </a:solidFill>
@@ -11371,8 +11743,8 @@
         </p:nvSpPr>
         <p:spPr>
           <a:xfrm>
-            <a:off x="5120640" y="6501384"/>
-            <a:ext cx="3566160" cy="201168"/>
+            <a:off x="5120640" y="6483096"/>
+            <a:ext cx="3566160" cy="219456"/>
           </a:xfrm>
           <a:prstGeom prst="rect">
             <a:avLst/>
@@ -11391,7 +11763,7 @@
               </a:lnSpc>
             </a:pPr>
             <a:r>
-              <a:rPr sz="750" b="0">
+              <a:rPr sz="840" b="0">
                 <a:solidFill>
                   <a:srgbClr val="7F8D9D"/>
                 </a:solidFill>
@@ -11410,8 +11782,8 @@
         </p:nvSpPr>
         <p:spPr>
           <a:xfrm>
-            <a:off x="11036808" y="6501384"/>
-            <a:ext cx="603504" cy="201168"/>
+            <a:off x="11036808" y="6483096"/>
+            <a:ext cx="603504" cy="219456"/>
           </a:xfrm>
           <a:prstGeom prst="rect">
             <a:avLst/>
@@ -11430,7 +11802,7 @@
               </a:lnSpc>
             </a:pPr>
             <a:r>
-              <a:rPr sz="750" b="0">
+              <a:rPr sz="840" b="0">
                 <a:solidFill>
                   <a:srgbClr val="606C7A"/>
                 </a:solidFill>

</xml_diff>

<commit_message>
Update presentation theme and formula
</commit_message>
<xml_diff>
--- a/public/materials/Qi_Heng_Interview_Presentation.pptx
+++ b/public/materials/Qi_Heng_Interview_Presentation.pptx
@@ -3089,7 +3089,7 @@
     <p:bg>
       <p:bgPr>
         <a:solidFill>
-          <a:srgbClr val="111F2B"/>
+          <a:srgbClr val="F8FAFC"/>
         </a:solidFill>
         <a:effectLst/>
       </p:bgPr>
@@ -3101,52 +3101,9 @@
         <p:nvPr/>
       </p:nvGrpSpPr>
       <p:grpSpPr/>
-      <p:sp>
-        <p:nvSpPr>
-          <p:cNvPr id="2" name="Rectangle 1"/>
-          <p:cNvSpPr/>
-          <p:nvPr/>
-        </p:nvSpPr>
-        <p:spPr>
-          <a:xfrm>
-            <a:off x="0" y="0"/>
-            <a:ext cx="12191999" cy="6858000"/>
-          </a:xfrm>
-          <a:prstGeom prst="rect">
-            <a:avLst/>
-          </a:prstGeom>
-          <a:solidFill>
-            <a:srgbClr val="111F2B"/>
-          </a:solidFill>
-          <a:ln>
-            <a:noFill/>
-          </a:ln>
-        </p:spPr>
-        <p:style>
-          <a:lnRef idx="1">
-            <a:schemeClr val="accent1"/>
-          </a:lnRef>
-          <a:fillRef idx="3">
-            <a:schemeClr val="accent1"/>
-          </a:fillRef>
-          <a:effectRef idx="2">
-            <a:schemeClr val="accent1"/>
-          </a:effectRef>
-          <a:fontRef idx="minor">
-            <a:schemeClr val="lt1"/>
-          </a:fontRef>
-        </p:style>
-        <p:txBody>
-          <a:bodyPr rtlCol="0" anchor="ctr"/>
-          <a:lstStyle/>
-          <a:p>
-            <a:pPr algn="ctr"/>
-          </a:p>
-        </p:txBody>
-      </p:sp>
       <p:pic>
         <p:nvPicPr>
-          <p:cNvPr id="3" name="Picture 2" descr="westlake_wave.png"/>
+          <p:cNvPr id="2" name="Picture 1" descr="westlake_wave.png"/>
           <p:cNvPicPr>
             <a:picLocks noChangeAspect="1"/>
           </p:cNvPicPr>
@@ -3160,8 +3117,8 @@
         </p:blipFill>
         <p:spPr>
           <a:xfrm>
-            <a:off x="0" y="4572000"/>
-            <a:ext cx="12191999" cy="2331720"/>
+            <a:off x="0" y="4599432"/>
+            <a:ext cx="12191999" cy="2258568"/>
           </a:xfrm>
           <a:prstGeom prst="rect">
             <a:avLst/>
@@ -3170,23 +3127,25 @@
       </p:pic>
       <p:sp>
         <p:nvSpPr>
-          <p:cNvPr id="4" name="Rectangle 3"/>
+          <p:cNvPr id="3" name="Rounded Rectangle 2"/>
           <p:cNvSpPr/>
           <p:nvPr/>
         </p:nvSpPr>
         <p:spPr>
           <a:xfrm>
-            <a:off x="8394192" y="0"/>
-            <a:ext cx="3794760" cy="6858000"/>
-          </a:xfrm>
-          <a:prstGeom prst="rect">
+            <a:off x="8101583" y="658368"/>
+            <a:ext cx="3419856" cy="5376672"/>
+          </a:xfrm>
+          <a:prstGeom prst="roundRect">
             <a:avLst/>
           </a:prstGeom>
           <a:solidFill>
-            <a:srgbClr val="E8F1F2"/>
+            <a:srgbClr val="FFFFFF"/>
           </a:solidFill>
-          <a:ln>
-            <a:noFill/>
+          <a:ln w="8890">
+            <a:solidFill>
+              <a:srgbClr val="D8E3EA"/>
+            </a:solidFill>
           </a:ln>
         </p:spPr>
         <p:style>
@@ -3213,7 +3172,7 @@
       </p:sp>
       <p:pic>
         <p:nvPicPr>
-          <p:cNvPr id="5" name="Picture 4" descr="headshot_square.jpg"/>
+          <p:cNvPr id="4" name="Picture 3" descr="headshot_square.jpg"/>
           <p:cNvPicPr>
             <a:picLocks noChangeAspect="1"/>
           </p:cNvPicPr>
@@ -3227,8 +3186,8 @@
         </p:blipFill>
         <p:spPr>
           <a:xfrm>
-            <a:off x="8942832" y="1042415"/>
-            <a:ext cx="2468880" cy="2468880"/>
+            <a:off x="8613648" y="987552"/>
+            <a:ext cx="2395728" cy="2395728"/>
           </a:xfrm>
           <a:prstGeom prst="rect">
             <a:avLst/>
@@ -3237,14 +3196,53 @@
       </p:pic>
       <p:sp>
         <p:nvSpPr>
+          <p:cNvPr id="5" name="TextBox 4"/>
+          <p:cNvSpPr txBox="1"/>
+          <p:nvPr/>
+        </p:nvSpPr>
+        <p:spPr>
+          <a:xfrm>
+            <a:off x="8394192" y="3639312"/>
+            <a:ext cx="2816352" cy="384048"/>
+          </a:xfrm>
+          <a:prstGeom prst="rect">
+            <a:avLst/>
+          </a:prstGeom>
+          <a:noFill/>
+        </p:spPr>
+        <p:txBody>
+          <a:bodyPr wrap="square" lIns="18288" rIns="18288" tIns="9144" bIns="9144" anchor="t">
+            <a:spAutoFit/>
+          </a:bodyPr>
+          <a:lstStyle/>
+          <a:p>
+            <a:pPr algn="ctr">
+              <a:lnSpc>
+                <a:spcPct val="108000"/>
+              </a:lnSpc>
+            </a:pPr>
+            <a:r>
+              <a:rPr sz="2400" b="1">
+                <a:solidFill>
+                  <a:srgbClr val="121B27"/>
+                </a:solidFill>
+                <a:latin typeface="PingFang SC"/>
+              </a:rPr>
+              <a:t>齐恒</a:t>
+            </a:r>
+          </a:p>
+        </p:txBody>
+      </p:sp>
+      <p:sp>
+        <p:nvSpPr>
           <p:cNvPr id="6" name="TextBox 5"/>
           <p:cNvSpPr txBox="1"/>
           <p:nvPr/>
         </p:nvSpPr>
         <p:spPr>
           <a:xfrm>
-            <a:off x="8705088" y="3794760"/>
-            <a:ext cx="2834640" cy="384048"/>
+            <a:off x="8375904" y="4105656"/>
+            <a:ext cx="2834640" cy="530352"/>
           </a:xfrm>
           <a:prstGeom prst="rect">
             <a:avLst/>
@@ -3263,50 +3261,11 @@
               </a:lnSpc>
             </a:pPr>
             <a:r>
-              <a:rPr sz="2400" b="1">
-                <a:solidFill>
-                  <a:srgbClr val="111F2B"/>
-                </a:solidFill>
-                <a:latin typeface="Hiragino Sans GB"/>
-              </a:rPr>
-              <a:t>齐恒</a:t>
-            </a:r>
-          </a:p>
-        </p:txBody>
-      </p:sp>
-      <p:sp>
-        <p:nvSpPr>
-          <p:cNvPr id="7" name="TextBox 6"/>
-          <p:cNvSpPr txBox="1"/>
-          <p:nvPr/>
-        </p:nvSpPr>
-        <p:spPr>
-          <a:xfrm>
-            <a:off x="8668512" y="4261104"/>
-            <a:ext cx="2907792" cy="530352"/>
-          </a:xfrm>
-          <a:prstGeom prst="rect">
-            <a:avLst/>
-          </a:prstGeom>
-          <a:noFill/>
-        </p:spPr>
-        <p:txBody>
-          <a:bodyPr wrap="square" lIns="18288" rIns="18288" tIns="9144" bIns="9144" anchor="t">
-            <a:spAutoFit/>
-          </a:bodyPr>
-          <a:lstStyle/>
-          <a:p>
-            <a:pPr algn="ctr">
-              <a:lnSpc>
-                <a:spcPct val="108000"/>
-              </a:lnSpc>
-            </a:pPr>
-            <a:r>
               <a:rPr sz="1050" b="0">
                 <a:solidFill>
                   <a:srgbClr val="2A3440"/>
                 </a:solidFill>
-                <a:latin typeface="Hiragino Sans GB"/>
+                <a:latin typeface="PingFang SC"/>
               </a:rPr>
               <a:t>东华大学物理学院
 应用物理学（新能源与微电子）</a:t>
@@ -3316,14 +3275,14 @@
       </p:sp>
       <p:sp>
         <p:nvSpPr>
-          <p:cNvPr id="8" name="TextBox 7"/>
-          <p:cNvSpPr txBox="1"/>
-          <p:nvPr/>
-        </p:nvSpPr>
-        <p:spPr>
-          <a:xfrm>
-            <a:off x="10561320" y="384048"/>
-            <a:ext cx="566928" cy="256032"/>
+          <p:cNvPr id="7" name="TextBox 6"/>
+          <p:cNvSpPr txBox="1"/>
+          <p:nvPr/>
+        </p:nvSpPr>
+        <p:spPr>
+          <a:xfrm>
+            <a:off x="10561320" y="877824"/>
+            <a:ext cx="438912" cy="201168"/>
           </a:xfrm>
           <a:prstGeom prst="rect">
             <a:avLst/>
@@ -3342,7 +3301,7 @@
               </a:lnSpc>
             </a:pPr>
             <a:r>
-              <a:rPr sz="1100" b="1">
+              <a:rPr sz="1000" b="1">
                 <a:solidFill>
                   <a:srgbClr val="127584"/>
                 </a:solidFill>
@@ -3355,20 +3314,20 @@
       </p:sp>
       <p:sp>
         <p:nvSpPr>
-          <p:cNvPr id="9" name="Rounded Rectangle 8"/>
+          <p:cNvPr id="8" name="Rounded Rectangle 7"/>
           <p:cNvSpPr/>
           <p:nvPr/>
         </p:nvSpPr>
         <p:spPr>
           <a:xfrm>
-            <a:off x="8668512" y="5047488"/>
+            <a:off x="8321040" y="4791456"/>
             <a:ext cx="1508760" cy="310896"/>
           </a:xfrm>
           <a:prstGeom prst="roundRect">
             <a:avLst/>
           </a:prstGeom>
           <a:solidFill>
-            <a:srgbClr val="FFFFFF"/>
+            <a:srgbClr val="EEF7F8"/>
           </a:solidFill>
           <a:ln w="10160">
             <a:solidFill>
@@ -3400,13 +3359,13 @@
       </p:sp>
       <p:sp>
         <p:nvSpPr>
-          <p:cNvPr id="10" name="TextBox 9"/>
-          <p:cNvSpPr txBox="1"/>
-          <p:nvPr/>
-        </p:nvSpPr>
-        <p:spPr>
-          <a:xfrm>
-            <a:off x="8741664" y="5129783"/>
+          <p:cNvPr id="9" name="TextBox 8"/>
+          <p:cNvSpPr txBox="1"/>
+          <p:nvPr/>
+        </p:nvSpPr>
+        <p:spPr>
+          <a:xfrm>
+            <a:off x="8394192" y="4873752"/>
             <a:ext cx="1362456" cy="137160"/>
           </a:xfrm>
           <a:prstGeom prst="rect">
@@ -3430,7 +3389,7 @@
                 <a:solidFill>
                   <a:srgbClr val="127584"/>
                 </a:solidFill>
-                <a:latin typeface="Hiragino Sans GB"/>
+                <a:latin typeface="PingFang SC"/>
               </a:rPr>
               <a:t>GPA 3.91/5.00</a:t>
             </a:r>
@@ -3439,20 +3398,20 @@
       </p:sp>
       <p:sp>
         <p:nvSpPr>
-          <p:cNvPr id="11" name="Rounded Rectangle 10"/>
+          <p:cNvPr id="10" name="Rounded Rectangle 9"/>
           <p:cNvSpPr/>
           <p:nvPr/>
         </p:nvSpPr>
         <p:spPr>
           <a:xfrm>
-            <a:off x="10314432" y="5047488"/>
+            <a:off x="9976104" y="4791456"/>
             <a:ext cx="1225296" cy="310896"/>
           </a:xfrm>
           <a:prstGeom prst="roundRect">
             <a:avLst/>
           </a:prstGeom>
           <a:solidFill>
-            <a:srgbClr val="FFFFFF"/>
+            <a:srgbClr val="EEF6F0"/>
           </a:solidFill>
           <a:ln w="10160">
             <a:solidFill>
@@ -3484,13 +3443,13 @@
       </p:sp>
       <p:sp>
         <p:nvSpPr>
-          <p:cNvPr id="12" name="TextBox 11"/>
-          <p:cNvSpPr txBox="1"/>
-          <p:nvPr/>
-        </p:nvSpPr>
-        <p:spPr>
-          <a:xfrm>
-            <a:off x="10387584" y="5129783"/>
+          <p:cNvPr id="11" name="TextBox 10"/>
+          <p:cNvSpPr txBox="1"/>
+          <p:nvPr/>
+        </p:nvSpPr>
+        <p:spPr>
+          <a:xfrm>
+            <a:off x="10049256" y="4873752"/>
             <a:ext cx="1078992" cy="137160"/>
           </a:xfrm>
           <a:prstGeom prst="rect">
@@ -3514,7 +3473,7 @@
                 <a:solidFill>
                   <a:srgbClr val="4F805E"/>
                 </a:solidFill>
-                <a:latin typeface="Hiragino Sans GB"/>
+                <a:latin typeface="PingFang SC"/>
               </a:rPr>
               <a:t>Rank 5/65</a:t>
             </a:r>
@@ -3523,14 +3482,14 @@
       </p:sp>
       <p:sp>
         <p:nvSpPr>
-          <p:cNvPr id="13" name="Rounded Rectangle 12"/>
+          <p:cNvPr id="12" name="Rounded Rectangle 11"/>
           <p:cNvSpPr/>
           <p:nvPr/>
         </p:nvSpPr>
         <p:spPr>
           <a:xfrm>
-            <a:off x="8805672" y="5486400"/>
-            <a:ext cx="859536" cy="859536"/>
+            <a:off x="8412480" y="5266944"/>
+            <a:ext cx="804672" cy="804672"/>
           </a:xfrm>
           <a:prstGeom prst="roundRect">
             <a:avLst/>
@@ -3568,7 +3527,7 @@
       </p:sp>
       <p:pic>
         <p:nvPicPr>
-          <p:cNvPr id="14" name="Picture 13" descr="homepage_qr.png"/>
+          <p:cNvPr id="13" name="Picture 12" descr="homepage_qr.png"/>
           <p:cNvPicPr>
             <a:picLocks noChangeAspect="1"/>
           </p:cNvPicPr>
@@ -3582,8 +3541,8 @@
         </p:blipFill>
         <p:spPr>
           <a:xfrm>
-            <a:off x="8860536" y="5541264"/>
-            <a:ext cx="749808" cy="749808"/>
+            <a:off x="8467344" y="5321807"/>
+            <a:ext cx="694944" cy="694944"/>
           </a:xfrm>
           <a:prstGeom prst="rect">
             <a:avLst/>
@@ -3592,27 +3551,66 @@
       </p:pic>
       <p:sp>
         <p:nvSpPr>
+          <p:cNvPr id="14" name="TextBox 13"/>
+          <p:cNvSpPr txBox="1"/>
+          <p:nvPr/>
+        </p:nvSpPr>
+        <p:spPr>
+          <a:xfrm>
+            <a:off x="8321040" y="6126479"/>
+            <a:ext cx="1005840" cy="182880"/>
+          </a:xfrm>
+          <a:prstGeom prst="rect">
+            <a:avLst/>
+          </a:prstGeom>
+          <a:noFill/>
+        </p:spPr>
+        <p:txBody>
+          <a:bodyPr wrap="square" lIns="18288" rIns="18288" tIns="9144" bIns="9144" anchor="t">
+            <a:spAutoFit/>
+          </a:bodyPr>
+          <a:lstStyle/>
+          <a:p>
+            <a:pPr algn="ctr">
+              <a:lnSpc>
+                <a:spcPct val="108000"/>
+              </a:lnSpc>
+            </a:pPr>
+            <a:r>
+              <a:rPr sz="880" b="1">
+                <a:solidFill>
+                  <a:srgbClr val="127584"/>
+                </a:solidFill>
+                <a:latin typeface="PingFang SC"/>
+              </a:rPr>
+              <a:t>扫码看个人主页</a:t>
+            </a:r>
+          </a:p>
+        </p:txBody>
+      </p:sp>
+      <p:sp>
+        <p:nvSpPr>
           <p:cNvPr id="15" name="TextBox 14"/>
           <p:cNvSpPr txBox="1"/>
           <p:nvPr/>
         </p:nvSpPr>
         <p:spPr>
           <a:xfrm>
-            <a:off x="8714232" y="6400800"/>
-            <a:ext cx="1060704" cy="182880"/>
-          </a:xfrm>
-          <a:prstGeom prst="rect">
-            <a:avLst/>
-          </a:prstGeom>
-          <a:noFill/>
-        </p:spPr>
-        <p:txBody>
-          <a:bodyPr wrap="square" lIns="18288" rIns="18288" tIns="9144" bIns="9144" anchor="t">
-            <a:spAutoFit/>
-          </a:bodyPr>
-          <a:lstStyle/>
-          <a:p>
-            <a:pPr algn="ctr">
+            <a:off x="9308592" y="5422392"/>
+            <a:ext cx="1737360" cy="182880"/>
+          </a:xfrm>
+          <a:prstGeom prst="rect">
+            <a:avLst/>
+          </a:prstGeom>
+          <a:noFill/>
+        </p:spPr>
+        <p:txBody>
+          <a:bodyPr wrap="square" lIns="18288" rIns="18288" tIns="9144" bIns="9144" anchor="t">
+            <a:spAutoFit/>
+          </a:bodyPr>
+          <a:lstStyle/>
+          <a:p>
+            <a:pPr algn="l">
               <a:lnSpc>
                 <a:spcPct val="108000"/>
               </a:lnSpc>
@@ -3622,9 +3620,9 @@
                 <a:solidFill>
                   <a:srgbClr val="127584"/>
                 </a:solidFill>
-                <a:latin typeface="Hiragino Sans GB"/>
-              </a:rPr>
-              <a:t>扫码看个人主页</a:t>
+                <a:latin typeface="Aptos"/>
+              </a:rPr>
+              <a:t>hengqi61-maker.github.io</a:t>
             </a:r>
           </a:p>
         </p:txBody>
@@ -3637,8 +3635,8 @@
         </p:nvSpPr>
         <p:spPr>
           <a:xfrm>
-            <a:off x="9765792" y="5660136"/>
-            <a:ext cx="1691640" cy="182880"/>
+            <a:off x="9308592" y="5678424"/>
+            <a:ext cx="1700784" cy="201168"/>
           </a:xfrm>
           <a:prstGeom prst="rect">
             <a:avLst/>
@@ -3657,50 +3655,11 @@
               </a:lnSpc>
             </a:pPr>
             <a:r>
-              <a:rPr sz="900" b="1">
-                <a:solidFill>
-                  <a:srgbClr val="127584"/>
-                </a:solidFill>
-                <a:latin typeface="Aptos"/>
-              </a:rPr>
-              <a:t>hengqi61-maker.github.io</a:t>
-            </a:r>
-          </a:p>
-        </p:txBody>
-      </p:sp>
-      <p:sp>
-        <p:nvSpPr>
-          <p:cNvPr id="17" name="TextBox 16"/>
-          <p:cNvSpPr txBox="1"/>
-          <p:nvPr/>
-        </p:nvSpPr>
-        <p:spPr>
-          <a:xfrm>
-            <a:off x="9765792" y="5925312"/>
-            <a:ext cx="1627632" cy="201168"/>
-          </a:xfrm>
-          <a:prstGeom prst="rect">
-            <a:avLst/>
-          </a:prstGeom>
-          <a:noFill/>
-        </p:spPr>
-        <p:txBody>
-          <a:bodyPr wrap="square" lIns="18288" rIns="18288" tIns="9144" bIns="9144" anchor="t">
-            <a:spAutoFit/>
-          </a:bodyPr>
-          <a:lstStyle/>
-          <a:p>
-            <a:pPr algn="l">
-              <a:lnSpc>
-                <a:spcPct val="108000"/>
-              </a:lnSpc>
-            </a:pPr>
-            <a:r>
-              <a:rPr sz="850" b="0">
+              <a:rPr sz="830" b="0">
                 <a:solidFill>
                   <a:srgbClr val="606C7A"/>
                 </a:solidFill>
-                <a:latin typeface="Hiragino Sans GB"/>
+                <a:latin typeface="PingFang SC"/>
               </a:rPr>
               <a:t>项目入口 · 个人经历 · GitHub</a:t>
             </a:r>
@@ -3709,7 +3668,7 @@
       </p:sp>
       <p:sp>
         <p:nvSpPr>
-          <p:cNvPr id="18" name="Rectangle 17"/>
+          <p:cNvPr id="17" name="Rectangle 16"/>
           <p:cNvSpPr/>
           <p:nvPr/>
         </p:nvSpPr>
@@ -3722,7 +3681,7 @@
             <a:avLst/>
           </a:prstGeom>
           <a:solidFill>
-            <a:srgbClr val="DFEFF3"/>
+            <a:srgbClr val="127584"/>
           </a:solidFill>
           <a:ln>
             <a:noFill/>
@@ -3752,7 +3711,7 @@
       </p:sp>
       <p:sp>
         <p:nvSpPr>
-          <p:cNvPr id="19" name="TextBox 18"/>
+          <p:cNvPr id="18" name="TextBox 17"/>
           <p:cNvSpPr txBox="1"/>
           <p:nvPr/>
         </p:nvSpPr>
@@ -3780,7 +3739,7 @@
             <a:r>
               <a:rPr sz="850" b="1">
                 <a:solidFill>
-                  <a:srgbClr val="DFEFF3"/>
+                  <a:srgbClr val="606C7A"/>
                 </a:solidFill>
                 <a:latin typeface="Aptos"/>
               </a:rPr>
@@ -3791,7 +3750,7 @@
       </p:sp>
       <p:sp>
         <p:nvSpPr>
-          <p:cNvPr id="20" name="TextBox 19"/>
+          <p:cNvPr id="19" name="TextBox 18"/>
           <p:cNvSpPr txBox="1"/>
           <p:nvPr/>
         </p:nvSpPr>
@@ -3819,9 +3778,9 @@
             <a:r>
               <a:rPr sz="900" b="0">
                 <a:solidFill>
-                  <a:srgbClr val="DFEFF3"/>
-                </a:solidFill>
-                <a:latin typeface="Hiragino Sans GB"/>
+                  <a:srgbClr val="606C7A"/>
+                </a:solidFill>
+                <a:latin typeface="PingFang SC"/>
               </a:rPr>
               <a:t>个人成果汇报</a:t>
             </a:r>
@@ -3830,7 +3789,7 @@
       </p:sp>
       <p:sp>
         <p:nvSpPr>
-          <p:cNvPr id="21" name="TextBox 20"/>
+          <p:cNvPr id="20" name="TextBox 19"/>
           <p:cNvSpPr txBox="1"/>
           <p:nvPr/>
         </p:nvSpPr>
@@ -3858,9 +3817,9 @@
             <a:r>
               <a:rPr sz="1300" b="1">
                 <a:solidFill>
-                  <a:srgbClr val="DFEFF3"/>
-                </a:solidFill>
-                <a:latin typeface="Hiragino Sans GB"/>
+                  <a:srgbClr val="127584"/>
+                </a:solidFill>
+                <a:latin typeface="PingFang SC"/>
               </a:rPr>
               <a:t>西湖大学理学院夏令营</a:t>
             </a:r>
@@ -3869,7 +3828,7 @@
       </p:sp>
       <p:sp>
         <p:nvSpPr>
-          <p:cNvPr id="22" name="TextBox 21"/>
+          <p:cNvPr id="21" name="TextBox 20"/>
           <p:cNvSpPr txBox="1"/>
           <p:nvPr/>
         </p:nvSpPr>
@@ -3897,9 +3856,9 @@
             <a:r>
               <a:rPr sz="3400" b="1">
                 <a:solidFill>
-                  <a:srgbClr val="FFFFFF"/>
-                </a:solidFill>
-                <a:latin typeface="Hiragino Sans GB"/>
+                  <a:srgbClr val="121B27"/>
+                </a:solidFill>
+                <a:latin typeface="PingFang SC"/>
               </a:rPr>
               <a:t>从物理问题到
 </a:t>
@@ -3907,9 +3866,9 @@
             <a:r>
               <a:rPr sz="3400" b="1">
                 <a:solidFill>
-                  <a:srgbClr val="B7E2E0"/>
-                </a:solidFill>
-                <a:latin typeface="Hiragino Sans GB"/>
+                  <a:srgbClr val="127584"/>
+                </a:solidFill>
+                <a:latin typeface="PingFang SC"/>
               </a:rPr>
               <a:t>可复现计算系统</a:t>
             </a:r>
@@ -3918,7 +3877,7 @@
       </p:sp>
       <p:sp>
         <p:nvSpPr>
-          <p:cNvPr id="23" name="TextBox 22"/>
+          <p:cNvPr id="22" name="TextBox 21"/>
           <p:cNvSpPr txBox="1"/>
           <p:nvPr/>
         </p:nvSpPr>
@@ -3946,9 +3905,9 @@
             <a:r>
               <a:rPr sz="1400" b="1">
                 <a:solidFill>
-                  <a:srgbClr val="C8D8DC"/>
-                </a:solidFill>
-                <a:latin typeface="Hiragino Sans GB"/>
+                  <a:srgbClr val="2A3440"/>
+                </a:solidFill>
+                <a:latin typeface="PingFang SC"/>
               </a:rPr>
               <a:t>个人学术背景与博士阶段科研计划</a:t>
             </a:r>
@@ -3957,14 +3916,59 @@
       </p:sp>
       <p:sp>
         <p:nvSpPr>
+          <p:cNvPr id="23" name="Rounded Rectangle 22"/>
+          <p:cNvSpPr/>
+          <p:nvPr/>
+        </p:nvSpPr>
+        <p:spPr>
+          <a:xfrm>
+            <a:off x="621792" y="3858768"/>
+            <a:ext cx="6181344" cy="530352"/>
+          </a:xfrm>
+          <a:prstGeom prst="roundRect">
+            <a:avLst/>
+          </a:prstGeom>
+          <a:solidFill>
+            <a:srgbClr val="EDF5F5"/>
+          </a:solidFill>
+          <a:ln w="8890">
+            <a:solidFill>
+              <a:srgbClr val="C9DCDF"/>
+            </a:solidFill>
+          </a:ln>
+        </p:spPr>
+        <p:style>
+          <a:lnRef idx="1">
+            <a:schemeClr val="accent1"/>
+          </a:lnRef>
+          <a:fillRef idx="3">
+            <a:schemeClr val="accent1"/>
+          </a:fillRef>
+          <a:effectRef idx="2">
+            <a:schemeClr val="accent1"/>
+          </a:effectRef>
+          <a:fontRef idx="minor">
+            <a:schemeClr val="lt1"/>
+          </a:fontRef>
+        </p:style>
+        <p:txBody>
+          <a:bodyPr rtlCol="0" anchor="ctr"/>
+          <a:lstStyle/>
+          <a:p>
+            <a:pPr algn="ctr"/>
+          </a:p>
+        </p:txBody>
+      </p:sp>
+      <p:sp>
+        <p:nvSpPr>
           <p:cNvPr id="24" name="TextBox 23"/>
           <p:cNvSpPr txBox="1"/>
           <p:nvPr/>
         </p:nvSpPr>
         <p:spPr>
           <a:xfrm>
-            <a:off x="603504" y="3977639"/>
-            <a:ext cx="6446520" cy="292608"/>
+            <a:off x="850392" y="4041648"/>
+            <a:ext cx="5715000" cy="146304"/>
           </a:xfrm>
           <a:prstGeom prst="rect">
             <a:avLst/>
@@ -3983,13 +3987,13 @@
               </a:lnSpc>
             </a:pPr>
             <a:r>
-              <a:rPr sz="1250" b="0">
-                <a:solidFill>
-                  <a:srgbClr val="D8E7E8"/>
-                </a:solidFill>
-                <a:latin typeface="Hiragino Sans GB"/>
-              </a:rPr>
-              <a:t>主线：物理模型理解  →  数值模拟与可视化  →  AI for Science 工作流</a:t>
+              <a:rPr sz="1120" b="1">
+                <a:solidFill>
+                  <a:srgbClr val="127584"/>
+                </a:solidFill>
+                <a:latin typeface="PingFang SC"/>
+              </a:rPr>
+              <a:t>主线：物理模型理解  -&gt;  数值模拟与可视化  -&gt;  AI for Science 工作流</a:t>
             </a:r>
           </a:p>
         </p:txBody>
@@ -4024,7 +4028,7 @@
             <a:r>
               <a:rPr sz="900" b="0">
                 <a:solidFill>
-                  <a:srgbClr val="B8C9CE"/>
+                  <a:srgbClr val="606C7A"/>
                 </a:solidFill>
                 <a:latin typeface="Aptos"/>
               </a:rPr>
@@ -4173,7 +4177,7 @@
                 <a:solidFill>
                   <a:srgbClr val="606C7A"/>
                 </a:solidFill>
-                <a:latin typeface="Hiragino Sans GB"/>
+                <a:latin typeface="PingFang SC"/>
               </a:rPr>
               <a:t>学术背景</a:t>
             </a:r>
@@ -4212,7 +4216,7 @@
                 <a:solidFill>
                   <a:srgbClr val="121B27"/>
                 </a:solidFill>
-                <a:latin typeface="Hiragino Sans GB"/>
+                <a:latin typeface="PingFang SC"/>
               </a:rPr>
               <a:t>物理与数学课程构成后续计算训练的底座</a:t>
             </a:r>
@@ -4251,7 +4255,7 @@
                 <a:solidFill>
                   <a:srgbClr val="606C7A"/>
                 </a:solidFill>
-                <a:latin typeface="Hiragino Sans GB"/>
+                <a:latin typeface="PingFang SC"/>
               </a:rPr>
               <a:t>不堆叠证明材料，重点说明这些基础如何支撑建模、推导、数值实现和结果解释。</a:t>
             </a:r>
@@ -4374,7 +4378,7 @@
                 <a:solidFill>
                   <a:srgbClr val="606C7A"/>
                 </a:solidFill>
-                <a:latin typeface="Hiragino Sans GB"/>
+                <a:latin typeface="PingFang SC"/>
               </a:rPr>
               <a:t>GPA / 5.00</a:t>
             </a:r>
@@ -4497,7 +4501,7 @@
                 <a:solidFill>
                   <a:srgbClr val="606C7A"/>
                 </a:solidFill>
-                <a:latin typeface="Hiragino Sans GB"/>
+                <a:latin typeface="PingFang SC"/>
               </a:rPr>
               <a:t>百分制均分</a:t>
             </a:r>
@@ -4620,7 +4624,7 @@
                 <a:solidFill>
                   <a:srgbClr val="606C7A"/>
                 </a:solidFill>
-                <a:latin typeface="Hiragino Sans GB"/>
+                <a:latin typeface="PingFang SC"/>
               </a:rPr>
               <a:t>专业排名 · 前 7.7%</a:t>
             </a:r>
@@ -4743,7 +4747,7 @@
                 <a:solidFill>
                   <a:srgbClr val="606C7A"/>
                 </a:solidFill>
-                <a:latin typeface="Hiragino Sans GB"/>
+                <a:latin typeface="PingFang SC"/>
               </a:rPr>
               <a:t>CET-6</a:t>
             </a:r>
@@ -4827,7 +4831,7 @@
                 <a:solidFill>
                   <a:srgbClr val="121B27"/>
                 </a:solidFill>
-                <a:latin typeface="Hiragino Sans GB"/>
+                <a:latin typeface="PingFang SC"/>
               </a:rPr>
               <a:t>核心课程</a:t>
             </a:r>
@@ -4866,7 +4870,7 @@
                 <a:solidFill>
                   <a:srgbClr val="606C7A"/>
                 </a:solidFill>
-                <a:latin typeface="Hiragino Sans GB"/>
+                <a:latin typeface="PingFang SC"/>
               </a:rPr>
               <a:t>经典力学</a:t>
             </a:r>
@@ -5030,7 +5034,7 @@
                 <a:solidFill>
                   <a:srgbClr val="606C7A"/>
                 </a:solidFill>
-                <a:latin typeface="Hiragino Sans GB"/>
+                <a:latin typeface="PingFang SC"/>
               </a:rPr>
               <a:t>光学</a:t>
             </a:r>
@@ -5194,7 +5198,7 @@
                 <a:solidFill>
                   <a:srgbClr val="606C7A"/>
                 </a:solidFill>
-                <a:latin typeface="Hiragino Sans GB"/>
+                <a:latin typeface="PingFang SC"/>
               </a:rPr>
               <a:t>数学物理方法</a:t>
             </a:r>
@@ -5358,7 +5362,7 @@
                 <a:solidFill>
                   <a:srgbClr val="606C7A"/>
                 </a:solidFill>
-                <a:latin typeface="Hiragino Sans GB"/>
+                <a:latin typeface="PingFang SC"/>
               </a:rPr>
               <a:t>线性代数</a:t>
             </a:r>
@@ -5522,7 +5526,7 @@
                 <a:solidFill>
                   <a:srgbClr val="606C7A"/>
                 </a:solidFill>
-                <a:latin typeface="Hiragino Sans GB"/>
+                <a:latin typeface="PingFang SC"/>
               </a:rPr>
               <a:t>偏微分方程</a:t>
             </a:r>
@@ -5686,7 +5690,7 @@
                 <a:solidFill>
                   <a:srgbClr val="606C7A"/>
                 </a:solidFill>
-                <a:latin typeface="Hiragino Sans GB"/>
+                <a:latin typeface="PingFang SC"/>
               </a:rPr>
               <a:t>量子力学</a:t>
             </a:r>
@@ -5850,7 +5854,7 @@
                 <a:solidFill>
                   <a:srgbClr val="606C7A"/>
                 </a:solidFill>
-                <a:latin typeface="Hiragino Sans GB"/>
+                <a:latin typeface="PingFang SC"/>
               </a:rPr>
               <a:t>电磁学</a:t>
             </a:r>
@@ -6014,7 +6018,7 @@
                 <a:solidFill>
                   <a:srgbClr val="606C7A"/>
                 </a:solidFill>
-                <a:latin typeface="Hiragino Sans GB"/>
+                <a:latin typeface="PingFang SC"/>
               </a:rPr>
               <a:t>固体物理</a:t>
             </a:r>
@@ -6305,7 +6309,7 @@
                 <a:solidFill>
                   <a:srgbClr val="121B27"/>
                 </a:solidFill>
-                <a:latin typeface="Hiragino Sans GB"/>
+                <a:latin typeface="PingFang SC"/>
               </a:rPr>
               <a:t>物理图像</a:t>
             </a:r>
@@ -6344,7 +6348,7 @@
                 <a:solidFill>
                   <a:srgbClr val="606C7A"/>
                 </a:solidFill>
-                <a:latin typeface="Hiragino Sans GB"/>
+                <a:latin typeface="PingFang SC"/>
               </a:rPr>
               <a:t>从经典、量子、电磁和固体物理中识别模型对象与适用边界。</a:t>
             </a:r>
@@ -6510,7 +6514,7 @@
                 <a:solidFill>
                   <a:srgbClr val="121B27"/>
                 </a:solidFill>
-                <a:latin typeface="Hiragino Sans GB"/>
+                <a:latin typeface="PingFang SC"/>
               </a:rPr>
               <a:t>数学表达</a:t>
             </a:r>
@@ -6549,7 +6553,7 @@
                 <a:solidFill>
                   <a:srgbClr val="606C7A"/>
                 </a:solidFill>
-                <a:latin typeface="Hiragino Sans GB"/>
+                <a:latin typeface="PingFang SC"/>
               </a:rPr>
               <a:t>用数学物理方法、线性代数和偏微分方程承接推导与离散化。</a:t>
             </a:r>
@@ -6715,7 +6719,7 @@
                 <a:solidFill>
                   <a:srgbClr val="121B27"/>
                 </a:solidFill>
-                <a:latin typeface="Hiragino Sans GB"/>
+                <a:latin typeface="PingFang SC"/>
               </a:rPr>
               <a:t>计算实现</a:t>
             </a:r>
@@ -6754,7 +6758,7 @@
                 <a:solidFill>
                   <a:srgbClr val="606C7A"/>
                 </a:solidFill>
-                <a:latin typeface="Hiragino Sans GB"/>
+                <a:latin typeface="PingFang SC"/>
               </a:rPr>
               <a:t>用 Python / Matlab / LaTeX 将公式转化为可检验的数值流程。</a:t>
             </a:r>
@@ -6793,7 +6797,7 @@
                 <a:solidFill>
                   <a:srgbClr val="121B27"/>
                 </a:solidFill>
-                <a:latin typeface="Hiragino Sans GB"/>
+                <a:latin typeface="PingFang SC"/>
               </a:rPr>
               <a:t>结论：我申请西湖时的核心定位，不是单一软件能力，而是物理理解、数值建模和工程实现的组合。</a:t>
             </a:r>
@@ -6867,7 +6871,7 @@
                 <a:solidFill>
                   <a:srgbClr val="606C7A"/>
                 </a:solidFill>
-                <a:latin typeface="Hiragino Sans GB"/>
+                <a:latin typeface="PingFang SC"/>
               </a:rPr>
               <a:t>齐恒 · 东华大学物理学院 · 应用物理学（新能源与微电子）</a:t>
             </a:r>
@@ -6906,7 +6910,7 @@
                 <a:solidFill>
                   <a:srgbClr val="7F8D9D"/>
                 </a:solidFill>
-                <a:latin typeface="Hiragino Sans GB"/>
+                <a:latin typeface="PingFang SC"/>
               </a:rPr>
               <a:t>西湖大学理学院夏令营个人成果汇报</a:t>
             </a:r>
@@ -7092,7 +7096,7 @@
                 <a:solidFill>
                   <a:srgbClr val="606C7A"/>
                 </a:solidFill>
-                <a:latin typeface="Hiragino Sans GB"/>
+                <a:latin typeface="PingFang SC"/>
               </a:rPr>
               <a:t>完整的我</a:t>
             </a:r>
@@ -7131,7 +7135,7 @@
                 <a:solidFill>
                   <a:srgbClr val="121B27"/>
                 </a:solidFill>
-                <a:latin typeface="Hiragino Sans GB"/>
+                <a:latin typeface="PingFang SC"/>
               </a:rPr>
               <a:t>独立远行训练了我面对未知时的推进方式</a:t>
             </a:r>
@@ -7170,7 +7174,7 @@
                 <a:solidFill>
                   <a:srgbClr val="606C7A"/>
                 </a:solidFill>
-                <a:latin typeface="Hiragino Sans GB"/>
+                <a:latin typeface="PingFang SC"/>
               </a:rPr>
               <a:t>我不是把徒步当成装饰经历，而是把它理解为规划、判断风险、处理意外和复盘迭代的长期训练。</a:t>
             </a:r>
@@ -7326,7 +7330,7 @@
                 <a:solidFill>
                   <a:srgbClr val="121B27"/>
                 </a:solidFill>
-                <a:latin typeface="Hiragino Sans GB"/>
+                <a:latin typeface="PingFang SC"/>
               </a:rPr>
               <a:t>旅行与徒步给我的训练</a:t>
             </a:r>
@@ -7408,7 +7412,7 @@
                 <a:solidFill>
                   <a:srgbClr val="127584"/>
                 </a:solidFill>
-                <a:latin typeface="Hiragino Sans GB"/>
+                <a:latin typeface="PingFang SC"/>
               </a:rPr>
               <a:t>路线与预算</a:t>
             </a:r>
@@ -7447,7 +7451,7 @@
                 <a:solidFill>
                   <a:srgbClr val="606C7A"/>
                 </a:solidFill>
-                <a:latin typeface="Hiragino Sans GB"/>
+                <a:latin typeface="PingFang SC"/>
               </a:rPr>
               <a:t>把目标拆成路线、时间、装备、补给和预算。</a:t>
             </a:r>
@@ -7529,7 +7533,7 @@
                 <a:solidFill>
                   <a:srgbClr val="4F805E"/>
                 </a:solidFill>
-                <a:latin typeface="Hiragino Sans GB"/>
+                <a:latin typeface="PingFang SC"/>
               </a:rPr>
               <a:t>风险判断</a:t>
             </a:r>
@@ -7568,7 +7572,7 @@
                 <a:solidFill>
                   <a:srgbClr val="606C7A"/>
                 </a:solidFill>
-                <a:latin typeface="Hiragino Sans GB"/>
+                <a:latin typeface="PingFang SC"/>
               </a:rPr>
               <a:t>在天气、迷路、设备和语言环境变化中快速决策。</a:t>
             </a:r>
@@ -7650,7 +7654,7 @@
                 <a:solidFill>
                   <a:srgbClr val="C48436"/>
                 </a:solidFill>
-                <a:latin typeface="Hiragino Sans GB"/>
+                <a:latin typeface="PingFang SC"/>
               </a:rPr>
               <a:t>复盘迭代</a:t>
             </a:r>
@@ -7689,7 +7693,7 @@
                 <a:solidFill>
                   <a:srgbClr val="606C7A"/>
                 </a:solidFill>
-                <a:latin typeface="Hiragino Sans GB"/>
+                <a:latin typeface="PingFang SC"/>
               </a:rPr>
               <a:t>把一次次问题转化为下一次更可靠的方案。</a:t>
             </a:r>
@@ -7773,7 +7777,7 @@
                 <a:solidFill>
                   <a:srgbClr val="127584"/>
                 </a:solidFill>
-                <a:latin typeface="Hiragino Sans GB"/>
+                <a:latin typeface="PingFang SC"/>
               </a:rPr>
               <a:t>迁移到科研训练</a:t>
             </a:r>
@@ -7812,7 +7816,7 @@
                 <a:solidFill>
                   <a:srgbClr val="121B27"/>
                 </a:solidFill>
-                <a:latin typeface="Hiragino Sans GB"/>
+                <a:latin typeface="PingFang SC"/>
               </a:rPr>
               <a:t>我现在的项目也沿用同一种方式：先做出可运行版本，再暴露问题、补齐知识、继续迭代。</a:t>
             </a:r>
@@ -7890,7 +7894,7 @@
                 <a:solidFill>
                   <a:srgbClr val="121B27"/>
                 </a:solidFill>
-                <a:latin typeface="Hiragino Sans GB"/>
+                <a:latin typeface="PingFang SC"/>
               </a:rPr>
               <a:t>不确定</a:t>
             </a:r>
@@ -7929,7 +7933,7 @@
                 <a:solidFill>
                   <a:srgbClr val="606C7A"/>
                 </a:solidFill>
-                <a:latin typeface="Hiragino Sans GB"/>
+                <a:latin typeface="PingFang SC"/>
               </a:rPr>
               <a:t>方向未完全收敛，但主动调研、联系老师、比较课题组。</a:t>
             </a:r>
@@ -8007,7 +8011,7 @@
                 <a:solidFill>
                   <a:srgbClr val="121B27"/>
                 </a:solidFill>
-                <a:latin typeface="Hiragino Sans GB"/>
+                <a:latin typeface="PingFang SC"/>
               </a:rPr>
               <a:t>可执行</a:t>
             </a:r>
@@ -8046,7 +8050,7 @@
                 <a:solidFill>
                   <a:srgbClr val="606C7A"/>
                 </a:solidFill>
-                <a:latin typeface="Hiragino Sans GB"/>
+                <a:latin typeface="PingFang SC"/>
               </a:rPr>
               <a:t>把模糊兴趣拆成公式、代码、图像和测试。</a:t>
             </a:r>
@@ -8124,7 +8128,7 @@
                 <a:solidFill>
                   <a:srgbClr val="121B27"/>
                 </a:solidFill>
-                <a:latin typeface="Hiragino Sans GB"/>
+                <a:latin typeface="PingFang SC"/>
               </a:rPr>
               <a:t>可复盘</a:t>
             </a:r>
@@ -8163,7 +8167,7 @@
                 <a:solidFill>
                   <a:srgbClr val="606C7A"/>
                 </a:solidFill>
-                <a:latin typeface="Hiragino Sans GB"/>
+                <a:latin typeface="PingFang SC"/>
               </a:rPr>
               <a:t>用网页、GitHub、文档保存过程，而不是只留下结果。</a:t>
             </a:r>
@@ -8202,7 +8206,7 @@
                 <a:solidFill>
                   <a:srgbClr val="121B27"/>
                 </a:solidFill>
-                <a:latin typeface="Hiragino Sans GB"/>
+                <a:latin typeface="PingFang SC"/>
               </a:rPr>
               <a:t>关键词：自驱探索 / 独立规划 / 快速试错 / 持续迭代</a:t>
             </a:r>
@@ -8276,7 +8280,7 @@
                 <a:solidFill>
                   <a:srgbClr val="606C7A"/>
                 </a:solidFill>
-                <a:latin typeface="Hiragino Sans GB"/>
+                <a:latin typeface="PingFang SC"/>
               </a:rPr>
               <a:t>齐恒 · 东华大学物理学院 · 应用物理学（新能源与微电子）</a:t>
             </a:r>
@@ -8315,7 +8319,7 @@
                 <a:solidFill>
                   <a:srgbClr val="7F8D9D"/>
                 </a:solidFill>
-                <a:latin typeface="Hiragino Sans GB"/>
+                <a:latin typeface="PingFang SC"/>
               </a:rPr>
               <a:t>西湖大学理学院夏令营个人成果汇报</a:t>
             </a:r>
@@ -8501,7 +8505,7 @@
                 <a:solidFill>
                   <a:srgbClr val="606C7A"/>
                 </a:solidFill>
-                <a:latin typeface="Hiragino Sans GB"/>
+                <a:latin typeface="PingFang SC"/>
               </a:rPr>
               <a:t>项目证据</a:t>
             </a:r>
@@ -8540,7 +8544,7 @@
                 <a:solidFill>
                   <a:srgbClr val="121B27"/>
                 </a:solidFill>
-                <a:latin typeface="Hiragino Sans GB"/>
+                <a:latin typeface="PingFang SC"/>
               </a:rPr>
               <a:t>项目重点不是“成果成熟”，而是自驱拆解和实现能力</a:t>
             </a:r>
@@ -8579,7 +8583,7 @@
                 <a:solidFill>
                   <a:srgbClr val="606C7A"/>
                 </a:solidFill>
-                <a:latin typeface="Hiragino Sans GB"/>
+                <a:latin typeface="PingFang SC"/>
               </a:rPr>
               <a:t>我更适合被理解为：能从一个真实问题出发，快速做出可运行系统，并在错误中继续收敛。</a:t>
             </a:r>
@@ -8687,7 +8691,7 @@
                 <a:solidFill>
                   <a:srgbClr val="127584"/>
                 </a:solidFill>
-                <a:latin typeface="Hiragino Sans GB"/>
+                <a:latin typeface="PingFang SC"/>
               </a:rPr>
               <a:t>扫码看主页</a:t>
             </a:r>
@@ -8726,7 +8730,7 @@
                 <a:solidFill>
                   <a:srgbClr val="127584"/>
                 </a:solidFill>
-                <a:latin typeface="Hiragino Sans GB"/>
+                <a:latin typeface="PingFang SC"/>
               </a:rPr>
               <a:t>个人主页与 GitHub</a:t>
             </a:r>
@@ -8864,8 +8868,8 @@
         </p:nvSpPr>
         <p:spPr>
           <a:xfrm>
-            <a:off x="877824" y="2368296"/>
-            <a:ext cx="2852928" cy="301752"/>
+            <a:off x="877824" y="2331720"/>
+            <a:ext cx="2852928" cy="502920"/>
           </a:xfrm>
           <a:prstGeom prst="rect">
             <a:avLst/>
@@ -8880,7 +8884,7 @@
           <a:p>
             <a:pPr algn="l">
               <a:lnSpc>
-                <a:spcPct val="108000"/>
+                <a:spcPct val="102000"/>
               </a:lnSpc>
             </a:pPr>
             <a:r>
@@ -8888,7 +8892,7 @@
                 <a:solidFill>
                   <a:srgbClr val="121B27"/>
                 </a:solidFill>
-                <a:latin typeface="Hiragino Sans GB"/>
+                <a:latin typeface="PingFang SC"/>
               </a:rPr>
               <a:t>氢原子轨道电子云</a:t>
             </a:r>
@@ -8927,7 +8931,7 @@
                 <a:solidFill>
                   <a:srgbClr val="127584"/>
                 </a:solidFill>
-                <a:latin typeface="Hiragino Sans GB"/>
+                <a:latin typeface="PingFang SC"/>
               </a:rPr>
               <a:t>问题来源</a:t>
             </a:r>
@@ -8966,7 +8970,7 @@
                 <a:solidFill>
                   <a:srgbClr val="606C7A"/>
                 </a:solidFill>
-                <a:latin typeface="Hiragino Sans GB"/>
+                <a:latin typeface="PingFang SC"/>
               </a:rPr>
               <a:t>想理解轨道形状到底应由什么定义，而不只是背图像。</a:t>
             </a:r>
@@ -9005,7 +9009,7 @@
                 <a:solidFill>
                   <a:srgbClr val="127584"/>
                 </a:solidFill>
-                <a:latin typeface="Hiragino Sans GB"/>
+                <a:latin typeface="PingFang SC"/>
               </a:rPr>
               <a:t>实现路径</a:t>
             </a:r>
@@ -9021,7 +9025,7 @@
         <p:spPr>
           <a:xfrm>
             <a:off x="1600200" y="3575304"/>
-            <a:ext cx="2139696" cy="374904"/>
+            <a:ext cx="2139696" cy="292608"/>
           </a:xfrm>
           <a:prstGeom prst="rect">
             <a:avLst/>
@@ -9044,16 +9048,85 @@
                 <a:solidFill>
                   <a:srgbClr val="606C7A"/>
                 </a:solidFill>
-                <a:latin typeface="Hiragino Sans GB"/>
-              </a:rPr>
-              <a:t>从 |psi(r,theta,phi)|^2 出发，用 Monte Carlo 采样和三维可视化检验理解。</a:t>
-            </a:r>
-          </a:p>
-        </p:txBody>
-      </p:sp>
-      <p:sp>
-        <p:nvSpPr>
-          <p:cNvPr id="19" name="TextBox 18"/>
+                <a:latin typeface="PingFang SC"/>
+              </a:rPr>
+              <a:t>以概率密度为对象，结合 Monte Carlo 采样和三维可视化检验理解。</a:t>
+            </a:r>
+          </a:p>
+        </p:txBody>
+      </p:sp>
+      <p:sp>
+        <p:nvSpPr>
+          <p:cNvPr id="19" name="Rounded Rectangle 18"/>
+          <p:cNvSpPr/>
+          <p:nvPr/>
+        </p:nvSpPr>
+        <p:spPr>
+          <a:xfrm>
+            <a:off x="1591056" y="3895344"/>
+            <a:ext cx="2157984" cy="320040"/>
+          </a:xfrm>
+          <a:prstGeom prst="roundRect">
+            <a:avLst/>
+          </a:prstGeom>
+          <a:solidFill>
+            <a:srgbClr val="F8FBFC"/>
+          </a:solidFill>
+          <a:ln w="8890">
+            <a:solidFill>
+              <a:srgbClr val="D7E5E8"/>
+            </a:solidFill>
+          </a:ln>
+        </p:spPr>
+        <p:style>
+          <a:lnRef idx="1">
+            <a:schemeClr val="accent1"/>
+          </a:lnRef>
+          <a:fillRef idx="3">
+            <a:schemeClr val="accent1"/>
+          </a:fillRef>
+          <a:effectRef idx="2">
+            <a:schemeClr val="accent1"/>
+          </a:effectRef>
+          <a:fontRef idx="minor">
+            <a:schemeClr val="lt1"/>
+          </a:fontRef>
+        </p:style>
+        <p:txBody>
+          <a:bodyPr rtlCol="0" anchor="ctr"/>
+          <a:lstStyle/>
+          <a:p>
+            <a:pPr algn="ctr"/>
+          </a:p>
+        </p:txBody>
+      </p:sp>
+      <p:pic>
+        <p:nvPicPr>
+          <p:cNvPr id="20" name="Picture 19" descr="orbital_density_formula.png"/>
+          <p:cNvPicPr>
+            <a:picLocks noChangeAspect="1"/>
+          </p:cNvPicPr>
+          <p:nvPr/>
+        </p:nvPicPr>
+        <p:blipFill>
+          <a:blip r:embed="rId3"/>
+          <a:stretch>
+            <a:fillRect/>
+          </a:stretch>
+        </p:blipFill>
+        <p:spPr>
+          <a:xfrm>
+            <a:off x="1719072" y="3954780"/>
+            <a:ext cx="1883664" cy="182880"/>
+          </a:xfrm>
+          <a:prstGeom prst="rect">
+            <a:avLst/>
+          </a:prstGeom>
+        </p:spPr>
+      </p:pic>
+      <p:sp>
+        <p:nvSpPr>
+          <p:cNvPr id="21" name="TextBox 20"/>
           <p:cNvSpPr txBox="1"/>
           <p:nvPr/>
         </p:nvSpPr>
@@ -9083,7 +9156,7 @@
                 <a:solidFill>
                   <a:srgbClr val="127584"/>
                 </a:solidFill>
-                <a:latin typeface="Hiragino Sans GB"/>
+                <a:latin typeface="PingFang SC"/>
               </a:rPr>
               <a:t>证明能力</a:t>
             </a:r>
@@ -9092,7 +9165,7 @@
       </p:sp>
       <p:sp>
         <p:nvSpPr>
-          <p:cNvPr id="20" name="TextBox 19"/>
+          <p:cNvPr id="22" name="TextBox 21"/>
           <p:cNvSpPr txBox="1"/>
           <p:nvPr/>
         </p:nvSpPr>
@@ -9122,7 +9195,7 @@
                 <a:solidFill>
                   <a:srgbClr val="606C7A"/>
                 </a:solidFill>
-                <a:latin typeface="Hiragino Sans GB"/>
+                <a:latin typeface="PingFang SC"/>
               </a:rPr>
               <a:t>能把公式、概率分布、采样误差和可视化结果串起来。</a:t>
             </a:r>
@@ -9131,7 +9204,7 @@
       </p:sp>
       <p:sp>
         <p:nvSpPr>
-          <p:cNvPr id="21" name="Rounded Rectangle 20"/>
+          <p:cNvPr id="23" name="Rounded Rectangle 22"/>
           <p:cNvSpPr/>
           <p:nvPr/>
         </p:nvSpPr>
@@ -9176,7 +9249,7 @@
       </p:sp>
       <p:sp>
         <p:nvSpPr>
-          <p:cNvPr id="22" name="TextBox 21"/>
+          <p:cNvPr id="24" name="TextBox 23"/>
           <p:cNvSpPr txBox="1"/>
           <p:nvPr/>
         </p:nvSpPr>
@@ -9215,14 +9288,14 @@
       </p:sp>
       <p:sp>
         <p:nvSpPr>
-          <p:cNvPr id="23" name="TextBox 22"/>
-          <p:cNvSpPr txBox="1"/>
-          <p:nvPr/>
-        </p:nvSpPr>
-        <p:spPr>
-          <a:xfrm>
-            <a:off x="4681728" y="2368296"/>
-            <a:ext cx="2852928" cy="301752"/>
+          <p:cNvPr id="25" name="TextBox 24"/>
+          <p:cNvSpPr txBox="1"/>
+          <p:nvPr/>
+        </p:nvSpPr>
+        <p:spPr>
+          <a:xfrm>
+            <a:off x="4681728" y="2331720"/>
+            <a:ext cx="2852928" cy="502920"/>
           </a:xfrm>
           <a:prstGeom prst="rect">
             <a:avLst/>
@@ -9237,7 +9310,7 @@
           <a:p>
             <a:pPr algn="l">
               <a:lnSpc>
-                <a:spcPct val="108000"/>
+                <a:spcPct val="102000"/>
               </a:lnSpc>
             </a:pPr>
             <a:r>
@@ -9245,7 +9318,7 @@
                 <a:solidFill>
                   <a:srgbClr val="121B27"/>
                 </a:solidFill>
-                <a:latin typeface="Hiragino Sans GB"/>
+                <a:latin typeface="PingFang SC"/>
               </a:rPr>
               <a:t>晶体结构与倒空间教具</a:t>
             </a:r>
@@ -9254,7 +9327,7 @@
       </p:sp>
       <p:sp>
         <p:nvSpPr>
-          <p:cNvPr id="24" name="TextBox 23"/>
+          <p:cNvPr id="26" name="TextBox 25"/>
           <p:cNvSpPr txBox="1"/>
           <p:nvPr/>
         </p:nvSpPr>
@@ -9284,7 +9357,7 @@
                 <a:solidFill>
                   <a:srgbClr val="4F805E"/>
                 </a:solidFill>
-                <a:latin typeface="Hiragino Sans GB"/>
+                <a:latin typeface="PingFang SC"/>
               </a:rPr>
               <a:t>问题来源</a:t>
             </a:r>
@@ -9293,7 +9366,7 @@
       </p:sp>
       <p:sp>
         <p:nvSpPr>
-          <p:cNvPr id="25" name="TextBox 24"/>
+          <p:cNvPr id="27" name="TextBox 26"/>
           <p:cNvSpPr txBox="1"/>
           <p:nvPr/>
         </p:nvSpPr>
@@ -9323,7 +9396,7 @@
                 <a:solidFill>
                   <a:srgbClr val="606C7A"/>
                 </a:solidFill>
-                <a:latin typeface="Hiragino Sans GB"/>
+                <a:latin typeface="PingFang SC"/>
               </a:rPr>
               <a:t>固体物理中的 Miller 指数、倒格子、布里渊区较抽象。</a:t>
             </a:r>
@@ -9332,7 +9405,7 @@
       </p:sp>
       <p:sp>
         <p:nvSpPr>
-          <p:cNvPr id="26" name="TextBox 25"/>
+          <p:cNvPr id="28" name="TextBox 27"/>
           <p:cNvSpPr txBox="1"/>
           <p:nvPr/>
         </p:nvSpPr>
@@ -9362,7 +9435,7 @@
                 <a:solidFill>
                   <a:srgbClr val="4F805E"/>
                 </a:solidFill>
-                <a:latin typeface="Hiragino Sans GB"/>
+                <a:latin typeface="PingFang SC"/>
               </a:rPr>
               <a:t>实现路径</a:t>
             </a:r>
@@ -9371,7 +9444,7 @@
       </p:sp>
       <p:sp>
         <p:nvSpPr>
-          <p:cNvPr id="27" name="TextBox 26"/>
+          <p:cNvPr id="29" name="TextBox 28"/>
           <p:cNvSpPr txBox="1"/>
           <p:nvPr/>
         </p:nvSpPr>
@@ -9401,7 +9474,7 @@
                 <a:solidFill>
                   <a:srgbClr val="606C7A"/>
                 </a:solidFill>
-                <a:latin typeface="Hiragino Sans GB"/>
+                <a:latin typeface="PingFang SC"/>
               </a:rPr>
               <a:t>把 SC/BCC/FCC/HCP、正倒空间、Ewald 球等做成交互对象。</a:t>
             </a:r>
@@ -9410,7 +9483,7 @@
       </p:sp>
       <p:sp>
         <p:nvSpPr>
-          <p:cNvPr id="28" name="TextBox 27"/>
+          <p:cNvPr id="30" name="TextBox 29"/>
           <p:cNvSpPr txBox="1"/>
           <p:nvPr/>
         </p:nvSpPr>
@@ -9440,7 +9513,7 @@
                 <a:solidFill>
                   <a:srgbClr val="4F805E"/>
                 </a:solidFill>
-                <a:latin typeface="Hiragino Sans GB"/>
+                <a:latin typeface="PingFang SC"/>
               </a:rPr>
               <a:t>证明能力</a:t>
             </a:r>
@@ -9449,7 +9522,7 @@
       </p:sp>
       <p:sp>
         <p:nvSpPr>
-          <p:cNvPr id="29" name="TextBox 28"/>
+          <p:cNvPr id="31" name="TextBox 30"/>
           <p:cNvSpPr txBox="1"/>
           <p:nvPr/>
         </p:nvSpPr>
@@ -9479,7 +9552,7 @@
                 <a:solidFill>
                   <a:srgbClr val="606C7A"/>
                 </a:solidFill>
-                <a:latin typeface="Hiragino Sans GB"/>
+                <a:latin typeface="PingFang SC"/>
               </a:rPr>
               <a:t>能把空间几何关系转化为可观察、可调参的教学工具。</a:t>
             </a:r>
@@ -9488,7 +9561,7 @@
       </p:sp>
       <p:sp>
         <p:nvSpPr>
-          <p:cNvPr id="30" name="Rounded Rectangle 29"/>
+          <p:cNvPr id="32" name="Rounded Rectangle 31"/>
           <p:cNvSpPr/>
           <p:nvPr/>
         </p:nvSpPr>
@@ -9533,7 +9606,7 @@
       </p:sp>
       <p:sp>
         <p:nvSpPr>
-          <p:cNvPr id="31" name="TextBox 30"/>
+          <p:cNvPr id="33" name="TextBox 32"/>
           <p:cNvSpPr txBox="1"/>
           <p:nvPr/>
         </p:nvSpPr>
@@ -9572,14 +9645,14 @@
       </p:sp>
       <p:sp>
         <p:nvSpPr>
-          <p:cNvPr id="32" name="TextBox 31"/>
-          <p:cNvSpPr txBox="1"/>
-          <p:nvPr/>
-        </p:nvSpPr>
-        <p:spPr>
-          <a:xfrm>
-            <a:off x="8485632" y="2368296"/>
-            <a:ext cx="2852928" cy="301752"/>
+          <p:cNvPr id="34" name="TextBox 33"/>
+          <p:cNvSpPr txBox="1"/>
+          <p:nvPr/>
+        </p:nvSpPr>
+        <p:spPr>
+          <a:xfrm>
+            <a:off x="8485632" y="2331720"/>
+            <a:ext cx="2852928" cy="502920"/>
           </a:xfrm>
           <a:prstGeom prst="rect">
             <a:avLst/>
@@ -9594,24 +9667,25 @@
           <a:p>
             <a:pPr algn="l">
               <a:lnSpc>
-                <a:spcPct val="108000"/>
-              </a:lnSpc>
-            </a:pPr>
-            <a:r>
-              <a:rPr sz="1480" b="1">
+                <a:spcPct val="102000"/>
+              </a:lnSpc>
+            </a:pPr>
+            <a:r>
+              <a:rPr sz="1380" b="1">
                 <a:solidFill>
                   <a:srgbClr val="121B27"/>
                 </a:solidFill>
-                <a:latin typeface="Hiragino Sans GB"/>
-              </a:rPr>
-              <a:t>Memory Engine / Agent 工具</a:t>
-            </a:r>
-          </a:p>
-        </p:txBody>
-      </p:sp>
-      <p:sp>
-        <p:nvSpPr>
-          <p:cNvPr id="33" name="TextBox 32"/>
+                <a:latin typeface="PingFang SC"/>
+              </a:rPr>
+              <a:t>Memory Engine
+AI Agent 工具</a:t>
+            </a:r>
+          </a:p>
+        </p:txBody>
+      </p:sp>
+      <p:sp>
+        <p:nvSpPr>
+          <p:cNvPr id="35" name="TextBox 34"/>
           <p:cNvSpPr txBox="1"/>
           <p:nvPr/>
         </p:nvSpPr>
@@ -9641,7 +9715,7 @@
                 <a:solidFill>
                   <a:srgbClr val="665080"/>
                 </a:solidFill>
-                <a:latin typeface="Hiragino Sans GB"/>
+                <a:latin typeface="PingFang SC"/>
               </a:rPr>
               <a:t>问题来源</a:t>
             </a:r>
@@ -9650,7 +9724,7 @@
       </p:sp>
       <p:sp>
         <p:nvSpPr>
-          <p:cNvPr id="34" name="TextBox 33"/>
+          <p:cNvPr id="36" name="TextBox 35"/>
           <p:cNvSpPr txBox="1"/>
           <p:nvPr/>
         </p:nvSpPr>
@@ -9680,7 +9754,7 @@
                 <a:solidFill>
                   <a:srgbClr val="606C7A"/>
                 </a:solidFill>
-                <a:latin typeface="Hiragino Sans GB"/>
+                <a:latin typeface="PingFang SC"/>
               </a:rPr>
               <a:t>大模型上下文有限，重要信息容易遗忘，科研过程也需要长期记录。</a:t>
             </a:r>
@@ -9689,7 +9763,7 @@
       </p:sp>
       <p:sp>
         <p:nvSpPr>
-          <p:cNvPr id="35" name="TextBox 34"/>
+          <p:cNvPr id="37" name="TextBox 36"/>
           <p:cNvSpPr txBox="1"/>
           <p:nvPr/>
         </p:nvSpPr>
@@ -9719,7 +9793,7 @@
                 <a:solidFill>
                   <a:srgbClr val="665080"/>
                 </a:solidFill>
-                <a:latin typeface="Hiragino Sans GB"/>
+                <a:latin typeface="PingFang SC"/>
               </a:rPr>
               <a:t>实现路径</a:t>
             </a:r>
@@ -9728,7 +9802,7 @@
       </p:sp>
       <p:sp>
         <p:nvSpPr>
-          <p:cNvPr id="36" name="TextBox 35"/>
+          <p:cNvPr id="38" name="TextBox 37"/>
           <p:cNvSpPr txBox="1"/>
           <p:nvPr/>
         </p:nvSpPr>
@@ -9758,7 +9832,7 @@
                 <a:solidFill>
                   <a:srgbClr val="606C7A"/>
                 </a:solidFill>
-                <a:latin typeface="Hiragino Sans GB"/>
+                <a:latin typeface="PingFang SC"/>
               </a:rPr>
               <a:t>做长期记忆、语义检索、衰减、巩固和文档化流程。</a:t>
             </a:r>
@@ -9767,7 +9841,7 @@
       </p:sp>
       <p:sp>
         <p:nvSpPr>
-          <p:cNvPr id="37" name="TextBox 36"/>
+          <p:cNvPr id="39" name="TextBox 38"/>
           <p:cNvSpPr txBox="1"/>
           <p:nvPr/>
         </p:nvSpPr>
@@ -9797,7 +9871,7 @@
                 <a:solidFill>
                   <a:srgbClr val="665080"/>
                 </a:solidFill>
-                <a:latin typeface="Hiragino Sans GB"/>
+                <a:latin typeface="PingFang SC"/>
               </a:rPr>
               <a:t>证明能力</a:t>
             </a:r>
@@ -9806,7 +9880,7 @@
       </p:sp>
       <p:sp>
         <p:nvSpPr>
-          <p:cNvPr id="38" name="TextBox 37"/>
+          <p:cNvPr id="40" name="TextBox 39"/>
           <p:cNvSpPr txBox="1"/>
           <p:nvPr/>
         </p:nvSpPr>
@@ -9836,7 +9910,7 @@
                 <a:solidFill>
                   <a:srgbClr val="606C7A"/>
                 </a:solidFill>
-                <a:latin typeface="Hiragino Sans GB"/>
+                <a:latin typeface="PingFang SC"/>
               </a:rPr>
               <a:t>能用 AI 协作提升学习、代码实验和科研工作流效率。</a:t>
             </a:r>
@@ -9845,7 +9919,7 @@
       </p:sp>
       <p:sp>
         <p:nvSpPr>
-          <p:cNvPr id="39" name="Rounded Rectangle 38"/>
+          <p:cNvPr id="41" name="Rounded Rectangle 40"/>
           <p:cNvSpPr/>
           <p:nvPr/>
         </p:nvSpPr>
@@ -9890,7 +9964,7 @@
       </p:sp>
       <p:sp>
         <p:nvSpPr>
-          <p:cNvPr id="40" name="TextBox 39"/>
+          <p:cNvPr id="42" name="TextBox 41"/>
           <p:cNvSpPr txBox="1"/>
           <p:nvPr/>
         </p:nvSpPr>
@@ -9920,7 +9994,7 @@
                 <a:solidFill>
                   <a:srgbClr val="127584"/>
                 </a:solidFill>
-                <a:latin typeface="Hiragino Sans GB"/>
+                <a:latin typeface="PingFang SC"/>
               </a:rPr>
               <a:t>共同证明：我会主动找问题、做原型、验证和迭代。更多项目证据可扫码查看个人主页。</a:t>
             </a:r>
@@ -9929,7 +10003,7 @@
       </p:sp>
       <p:cxnSp>
         <p:nvCxnSpPr>
-          <p:cNvPr id="41" name="Connector 40"/>
+          <p:cNvPr id="43" name="Connector 42"/>
           <p:cNvCxnSpPr/>
           <p:nvPr/>
         </p:nvCxnSpPr>
@@ -9964,7 +10038,7 @@
       </p:cxnSp>
       <p:sp>
         <p:nvSpPr>
-          <p:cNvPr id="42" name="TextBox 41"/>
+          <p:cNvPr id="44" name="TextBox 43"/>
           <p:cNvSpPr txBox="1"/>
           <p:nvPr/>
         </p:nvSpPr>
@@ -9994,7 +10068,7 @@
                 <a:solidFill>
                   <a:srgbClr val="606C7A"/>
                 </a:solidFill>
-                <a:latin typeface="Hiragino Sans GB"/>
+                <a:latin typeface="PingFang SC"/>
               </a:rPr>
               <a:t>齐恒 · 东华大学物理学院 · 应用物理学（新能源与微电子）</a:t>
             </a:r>
@@ -10003,7 +10077,7 @@
       </p:sp>
       <p:sp>
         <p:nvSpPr>
-          <p:cNvPr id="43" name="TextBox 42"/>
+          <p:cNvPr id="45" name="TextBox 44"/>
           <p:cNvSpPr txBox="1"/>
           <p:nvPr/>
         </p:nvSpPr>
@@ -10033,7 +10107,7 @@
                 <a:solidFill>
                   <a:srgbClr val="7F8D9D"/>
                 </a:solidFill>
-                <a:latin typeface="Hiragino Sans GB"/>
+                <a:latin typeface="PingFang SC"/>
               </a:rPr>
               <a:t>西湖大学理学院夏令营个人成果汇报</a:t>
             </a:r>
@@ -10042,7 +10116,7 @@
       </p:sp>
       <p:sp>
         <p:nvSpPr>
-          <p:cNvPr id="44" name="TextBox 43"/>
+          <p:cNvPr id="46" name="TextBox 45"/>
           <p:cNvSpPr txBox="1"/>
           <p:nvPr/>
         </p:nvSpPr>
@@ -10219,7 +10293,7 @@
                 <a:solidFill>
                   <a:srgbClr val="606C7A"/>
                 </a:solidFill>
-                <a:latin typeface="Hiragino Sans GB"/>
+                <a:latin typeface="PingFang SC"/>
               </a:rPr>
               <a:t>博士阶段科研计划</a:t>
             </a:r>
@@ -10258,7 +10332,7 @@
                 <a:solidFill>
                   <a:srgbClr val="121B27"/>
                 </a:solidFill>
-                <a:latin typeface="Hiragino Sans GB"/>
+                <a:latin typeface="PingFang SC"/>
               </a:rPr>
               <a:t>博士阶段：从方向兴趣到可验证问题</a:t>
             </a:r>
@@ -10297,7 +10371,7 @@
                 <a:solidFill>
                   <a:srgbClr val="606C7A"/>
                 </a:solidFill>
-                <a:latin typeface="Hiragino Sans GB"/>
+                <a:latin typeface="PingFang SC"/>
               </a:rPr>
               <a:t>我不把博士计划写成锁死标签，而是把近期交流中的兴趣收束成可进入课题组继续深化的问题框架。</a:t>
             </a:r>
@@ -10381,7 +10455,7 @@
                 <a:solidFill>
                   <a:srgbClr val="121B27"/>
                 </a:solidFill>
-                <a:latin typeface="Hiragino Sans GB"/>
+                <a:latin typeface="PingFang SC"/>
               </a:rPr>
               <a:t>兴趣来源</a:t>
             </a:r>
@@ -10420,7 +10494,7 @@
                 <a:solidFill>
                   <a:srgbClr val="606C7A"/>
                 </a:solidFill>
-                <a:latin typeface="Hiragino Sans GB"/>
+                <a:latin typeface="PingFang SC"/>
               </a:rPr>
               <a:t>南科大夏令营交流让我集中接触到生物物理、凝聚态、计算物理 / AI 等方向。
 它们背后共同关心的是：结构、动力学与功能 / 物性如何连接。</a:t>
@@ -10540,7 +10614,7 @@
                 <a:solidFill>
                   <a:srgbClr val="127584"/>
                 </a:solidFill>
-                <a:latin typeface="Hiragino Sans GB"/>
+                <a:latin typeface="PingFang SC"/>
               </a:rPr>
               <a:t>核心问题</a:t>
             </a:r>
@@ -10579,7 +10653,7 @@
                 <a:solidFill>
                   <a:srgbClr val="121B27"/>
                 </a:solidFill>
-                <a:latin typeface="Hiragino Sans GB"/>
+                <a:latin typeface="PingFang SC"/>
               </a:rPr>
               <a:t>复杂体系中，微观结构如何产生动力学，
 动力学又如何决定生命功能或材料物性？</a:t>
@@ -10619,7 +10693,7 @@
                 <a:solidFill>
                   <a:srgbClr val="606C7A"/>
                 </a:solidFill>
-                <a:latin typeface="Hiragino Sans GB"/>
+                <a:latin typeface="PingFang SC"/>
               </a:rPr>
               <a:t>共同语言：结构 -&gt; 动力学 -&gt; 功能 / 物性 -&gt; 可解释模型</a:t>
             </a:r>
@@ -10738,7 +10812,7 @@
                 <a:solidFill>
                   <a:srgbClr val="121B27"/>
                 </a:solidFill>
-                <a:latin typeface="Hiragino Sans GB"/>
+                <a:latin typeface="PingFang SC"/>
               </a:rPr>
               <a:t>长期目标</a:t>
             </a:r>
@@ -10777,7 +10851,7 @@
                 <a:solidFill>
                   <a:srgbClr val="606C7A"/>
                 </a:solidFill>
-                <a:latin typeface="Hiragino Sans GB"/>
+                <a:latin typeface="PingFang SC"/>
               </a:rPr>
               <a:t>把物理直觉、计算方法和交叉科学问题连接起来。
 在具体课题组中，把兴趣收束为可计算、可验证、可解释的研究问题。</a:t>
@@ -10907,7 +10981,7 @@
                 <a:solidFill>
                   <a:srgbClr val="4F805E"/>
                 </a:solidFill>
-                <a:latin typeface="Hiragino Sans GB"/>
+                <a:latin typeface="PingFang SC"/>
               </a:rPr>
               <a:t>生物物理</a:t>
             </a:r>
@@ -10946,7 +11020,7 @@
                 <a:solidFill>
                   <a:srgbClr val="606C7A"/>
                 </a:solidFill>
-                <a:latin typeface="Hiragino Sans GB"/>
+                <a:latin typeface="PingFang SC"/>
               </a:rPr>
               <a:t>蛋白质构象、分子动力学、生命系统功能</a:t>
             </a:r>
@@ -11075,7 +11149,7 @@
                 <a:solidFill>
                   <a:srgbClr val="C48436"/>
                 </a:solidFill>
-                <a:latin typeface="Hiragino Sans GB"/>
+                <a:latin typeface="PingFang SC"/>
               </a:rPr>
               <a:t>凝聚态物理</a:t>
             </a:r>
@@ -11114,7 +11188,7 @@
                 <a:solidFill>
                   <a:srgbClr val="606C7A"/>
                 </a:solidFill>
-                <a:latin typeface="Hiragino Sans GB"/>
+                <a:latin typeface="PingFang SC"/>
               </a:rPr>
               <a:t>晶体结构、电子结构、材料物性与实验反馈</a:t>
             </a:r>
@@ -11243,7 +11317,7 @@
                 <a:solidFill>
                   <a:srgbClr val="665080"/>
                 </a:solidFill>
-                <a:latin typeface="Hiragino Sans GB"/>
+                <a:latin typeface="PingFang SC"/>
               </a:rPr>
               <a:t>计算物理 / AI</a:t>
             </a:r>
@@ -11282,7 +11356,7 @@
                 <a:solidFill>
                   <a:srgbClr val="606C7A"/>
                 </a:solidFill>
-                <a:latin typeface="Hiragino Sans GB"/>
+                <a:latin typeface="PingFang SC"/>
               </a:rPr>
               <a:t>数值模拟、机器学习、数据反演与模型解释</a:t>
             </a:r>
@@ -11321,7 +11395,7 @@
                 <a:solidFill>
                   <a:srgbClr val="121B27"/>
                 </a:solidFill>
-                <a:latin typeface="Hiragino Sans GB"/>
+                <a:latin typeface="PingFang SC"/>
               </a:rPr>
               <a:t>博士阶段的实际做法</a:t>
             </a:r>
@@ -11487,7 +11561,7 @@
                 <a:solidFill>
                   <a:srgbClr val="121B27"/>
                 </a:solidFill>
-                <a:latin typeface="Hiragino Sans GB"/>
+                <a:latin typeface="PingFang SC"/>
               </a:rPr>
               <a:t>补基础</a:t>
             </a:r>
@@ -11526,7 +11600,7 @@
                 <a:solidFill>
                   <a:srgbClr val="606C7A"/>
                 </a:solidFill>
-                <a:latin typeface="Hiragino Sans GB"/>
+                <a:latin typeface="PingFang SC"/>
               </a:rPr>
               <a:t>统计物理、凝聚态 / 生物物理、分子模拟或第一性原理、机器学习。</a:t>
             </a:r>
@@ -11692,7 +11766,7 @@
                 <a:solidFill>
                   <a:srgbClr val="121B27"/>
                 </a:solidFill>
-                <a:latin typeface="Hiragino Sans GB"/>
+                <a:latin typeface="PingFang SC"/>
               </a:rPr>
               <a:t>复现代表作</a:t>
             </a:r>
@@ -11731,7 +11805,7 @@
                 <a:solidFill>
                   <a:srgbClr val="606C7A"/>
                 </a:solidFill>
-                <a:latin typeface="Hiragino Sans GB"/>
+                <a:latin typeface="PingFang SC"/>
               </a:rPr>
               <a:t>复现方法与结果，训练文献阅读、代码复现和结果复核。</a:t>
             </a:r>
@@ -11897,7 +11971,7 @@
                 <a:solidFill>
                   <a:srgbClr val="121B27"/>
                 </a:solidFill>
-                <a:latin typeface="Hiragino Sans GB"/>
+                <a:latin typeface="PingFang SC"/>
               </a:rPr>
               <a:t>选具体体系</a:t>
             </a:r>
@@ -11936,7 +12010,7 @@
                 <a:solidFill>
                   <a:srgbClr val="606C7A"/>
                 </a:solidFill>
-                <a:latin typeface="Hiragino Sans GB"/>
+                <a:latin typeface="PingFang SC"/>
               </a:rPr>
               <a:t>跟随导师方向，在蛋白质或材料体系中找到可计算问题。</a:t>
             </a:r>
@@ -12102,7 +12176,7 @@
                 <a:solidFill>
                   <a:srgbClr val="121B27"/>
                 </a:solidFill>
-                <a:latin typeface="Hiragino Sans GB"/>
+                <a:latin typeface="PingFang SC"/>
               </a:rPr>
               <a:t>形成输出</a:t>
             </a:r>
@@ -12141,7 +12215,7 @@
                 <a:solidFill>
                   <a:srgbClr val="606C7A"/>
                 </a:solidFill>
-                <a:latin typeface="Hiragino Sans GB"/>
+                <a:latin typeface="PingFang SC"/>
               </a:rPr>
               <a:t>沉淀可复现代码、可验证模型和物理机制解释。</a:t>
             </a:r>
@@ -12215,7 +12289,7 @@
                 <a:solidFill>
                   <a:srgbClr val="606C7A"/>
                 </a:solidFill>
-                <a:latin typeface="Hiragino Sans GB"/>
+                <a:latin typeface="PingFang SC"/>
               </a:rPr>
               <a:t>齐恒 · 东华大学物理学院 · 应用物理学（新能源与微电子）</a:t>
             </a:r>
@@ -12254,7 +12328,7 @@
                 <a:solidFill>
                   <a:srgbClr val="7F8D9D"/>
                 </a:solidFill>
-                <a:latin typeface="Hiragino Sans GB"/>
+                <a:latin typeface="PingFang SC"/>
               </a:rPr>
               <a:t>西湖大学理学院夏令营个人成果汇报</a:t>
             </a:r>
@@ -12314,7 +12388,7 @@
     <p:bg>
       <p:bgPr>
         <a:solidFill>
-          <a:srgbClr val="111F2B"/>
+          <a:srgbClr val="F8FAFC"/>
         </a:solidFill>
         <a:effectLst/>
       </p:bgPr>
@@ -12334,252 +12408,10 @@
         </p:nvSpPr>
         <p:spPr>
           <a:xfrm>
-            <a:off x="0" y="0"/>
-            <a:ext cx="12191999" cy="6858000"/>
-          </a:xfrm>
-          <a:prstGeom prst="rect">
-            <a:avLst/>
-          </a:prstGeom>
-          <a:solidFill>
-            <a:srgbClr val="111F2B"/>
-          </a:solidFill>
-          <a:ln>
-            <a:noFill/>
-          </a:ln>
-        </p:spPr>
-        <p:style>
-          <a:lnRef idx="1">
-            <a:schemeClr val="accent1"/>
-          </a:lnRef>
-          <a:fillRef idx="3">
-            <a:schemeClr val="accent1"/>
-          </a:fillRef>
-          <a:effectRef idx="2">
-            <a:schemeClr val="accent1"/>
-          </a:effectRef>
-          <a:fontRef idx="minor">
-            <a:schemeClr val="lt1"/>
-          </a:fontRef>
-        </p:style>
-        <p:txBody>
-          <a:bodyPr rtlCol="0" anchor="ctr"/>
-          <a:lstStyle/>
-          <a:p>
-            <a:pPr algn="ctr"/>
-          </a:p>
-        </p:txBody>
-      </p:sp>
-      <p:sp>
-        <p:nvSpPr>
-          <p:cNvPr id="3" name="Rectangle 2"/>
-          <p:cNvSpPr/>
-          <p:nvPr/>
-        </p:nvSpPr>
-        <p:spPr>
-          <a:xfrm>
             <a:off x="566928" y="393192"/>
             <a:ext cx="82296" cy="228600"/>
           </a:xfrm>
           <a:prstGeom prst="rect">
-            <a:avLst/>
-          </a:prstGeom>
-          <a:solidFill>
-            <a:srgbClr val="DFEFF3"/>
-          </a:solidFill>
-          <a:ln>
-            <a:noFill/>
-          </a:ln>
-        </p:spPr>
-        <p:style>
-          <a:lnRef idx="1">
-            <a:schemeClr val="accent1"/>
-          </a:lnRef>
-          <a:fillRef idx="3">
-            <a:schemeClr val="accent1"/>
-          </a:fillRef>
-          <a:effectRef idx="2">
-            <a:schemeClr val="accent1"/>
-          </a:effectRef>
-          <a:fontRef idx="minor">
-            <a:schemeClr val="lt1"/>
-          </a:fontRef>
-        </p:style>
-        <p:txBody>
-          <a:bodyPr rtlCol="0" anchor="ctr"/>
-          <a:lstStyle/>
-          <a:p>
-            <a:pPr algn="ctr"/>
-          </a:p>
-        </p:txBody>
-      </p:sp>
-      <p:sp>
-        <p:nvSpPr>
-          <p:cNvPr id="4" name="TextBox 3"/>
-          <p:cNvSpPr txBox="1"/>
-          <p:nvPr/>
-        </p:nvSpPr>
-        <p:spPr>
-          <a:xfrm>
-            <a:off x="713232" y="347472"/>
-            <a:ext cx="2651760" cy="292608"/>
-          </a:xfrm>
-          <a:prstGeom prst="rect">
-            <a:avLst/>
-          </a:prstGeom>
-          <a:noFill/>
-        </p:spPr>
-        <p:txBody>
-          <a:bodyPr wrap="square" lIns="18288" rIns="18288" tIns="9144" bIns="9144" anchor="t">
-            <a:spAutoFit/>
-          </a:bodyPr>
-          <a:lstStyle/>
-          <a:p>
-            <a:pPr algn="l">
-              <a:lnSpc>
-                <a:spcPct val="108000"/>
-              </a:lnSpc>
-            </a:pPr>
-            <a:r>
-              <a:rPr sz="850" b="1">
-                <a:solidFill>
-                  <a:srgbClr val="DFEFF3"/>
-                </a:solidFill>
-                <a:latin typeface="Aptos"/>
-              </a:rPr>
-              <a:t>CLOSING</a:t>
-            </a:r>
-          </a:p>
-        </p:txBody>
-      </p:sp>
-      <p:sp>
-        <p:nvSpPr>
-          <p:cNvPr id="5" name="TextBox 4"/>
-          <p:cNvSpPr txBox="1"/>
-          <p:nvPr/>
-        </p:nvSpPr>
-        <p:spPr>
-          <a:xfrm>
-            <a:off x="10469880" y="347472"/>
-            <a:ext cx="1170432" cy="292608"/>
-          </a:xfrm>
-          <a:prstGeom prst="rect">
-            <a:avLst/>
-          </a:prstGeom>
-          <a:noFill/>
-        </p:spPr>
-        <p:txBody>
-          <a:bodyPr wrap="square" lIns="18288" rIns="18288" tIns="9144" bIns="9144" anchor="t">
-            <a:spAutoFit/>
-          </a:bodyPr>
-          <a:lstStyle/>
-          <a:p>
-            <a:pPr algn="r">
-              <a:lnSpc>
-                <a:spcPct val="108000"/>
-              </a:lnSpc>
-            </a:pPr>
-            <a:r>
-              <a:rPr sz="900" b="0">
-                <a:solidFill>
-                  <a:srgbClr val="DFEFF3"/>
-                </a:solidFill>
-                <a:latin typeface="Hiragino Sans GB"/>
-              </a:rPr>
-              <a:t>收束与问答</a:t>
-            </a:r>
-          </a:p>
-        </p:txBody>
-      </p:sp>
-      <p:sp>
-        <p:nvSpPr>
-          <p:cNvPr id="6" name="TextBox 5"/>
-          <p:cNvSpPr txBox="1"/>
-          <p:nvPr/>
-        </p:nvSpPr>
-        <p:spPr>
-          <a:xfrm>
-            <a:off x="640080" y="960120"/>
-            <a:ext cx="5669280" cy="411480"/>
-          </a:xfrm>
-          <a:prstGeom prst="rect">
-            <a:avLst/>
-          </a:prstGeom>
-          <a:noFill/>
-        </p:spPr>
-        <p:txBody>
-          <a:bodyPr wrap="square" lIns="18288" rIns="18288" tIns="9144" bIns="9144" anchor="t">
-            <a:spAutoFit/>
-          </a:bodyPr>
-          <a:lstStyle/>
-          <a:p>
-            <a:pPr algn="l">
-              <a:lnSpc>
-                <a:spcPct val="108000"/>
-              </a:lnSpc>
-            </a:pPr>
-            <a:r>
-              <a:rPr sz="2400" b="1">
-                <a:solidFill>
-                  <a:srgbClr val="FFFFFF"/>
-                </a:solidFill>
-                <a:latin typeface="Hiragino Sans GB"/>
-              </a:rPr>
-              <a:t>我希望西湖看到的是一个完整的人</a:t>
-            </a:r>
-          </a:p>
-        </p:txBody>
-      </p:sp>
-      <p:sp>
-        <p:nvSpPr>
-          <p:cNvPr id="7" name="TextBox 6"/>
-          <p:cNvSpPr txBox="1"/>
-          <p:nvPr/>
-        </p:nvSpPr>
-        <p:spPr>
-          <a:xfrm>
-            <a:off x="658368" y="1572768"/>
-            <a:ext cx="6035040" cy="292608"/>
-          </a:xfrm>
-          <a:prstGeom prst="rect">
-            <a:avLst/>
-          </a:prstGeom>
-          <a:noFill/>
-        </p:spPr>
-        <p:txBody>
-          <a:bodyPr wrap="square" lIns="18288" rIns="18288" tIns="9144" bIns="9144" anchor="t">
-            <a:spAutoFit/>
-          </a:bodyPr>
-          <a:lstStyle/>
-          <a:p>
-            <a:pPr algn="l">
-              <a:lnSpc>
-                <a:spcPct val="108000"/>
-              </a:lnSpc>
-            </a:pPr>
-            <a:r>
-              <a:rPr sz="1300" b="1">
-                <a:solidFill>
-                  <a:srgbClr val="CBDCE0"/>
-                </a:solidFill>
-                <a:latin typeface="Hiragino Sans GB"/>
-              </a:rPr>
-              <a:t>基础扎实，但还在收敛方向；成果不算成熟，但自驱探索和实现能力真实存在。</a:t>
-            </a:r>
-          </a:p>
-        </p:txBody>
-      </p:sp>
-      <p:sp>
-        <p:nvSpPr>
-          <p:cNvPr id="8" name="Oval 7"/>
-          <p:cNvSpPr/>
-          <p:nvPr/>
-        </p:nvSpPr>
-        <p:spPr>
-          <a:xfrm>
-            <a:off x="749808" y="2286000"/>
-            <a:ext cx="292608" cy="292608"/>
-          </a:xfrm>
-          <a:prstGeom prst="ellipse">
             <a:avLst/>
           </a:prstGeom>
           <a:solidFill>
@@ -12613,6 +12445,250 @@
       </p:sp>
       <p:sp>
         <p:nvSpPr>
+          <p:cNvPr id="3" name="TextBox 2"/>
+          <p:cNvSpPr txBox="1"/>
+          <p:nvPr/>
+        </p:nvSpPr>
+        <p:spPr>
+          <a:xfrm>
+            <a:off x="713232" y="347472"/>
+            <a:ext cx="2651760" cy="292608"/>
+          </a:xfrm>
+          <a:prstGeom prst="rect">
+            <a:avLst/>
+          </a:prstGeom>
+          <a:noFill/>
+        </p:spPr>
+        <p:txBody>
+          <a:bodyPr wrap="square" lIns="18288" rIns="18288" tIns="9144" bIns="9144" anchor="t">
+            <a:spAutoFit/>
+          </a:bodyPr>
+          <a:lstStyle/>
+          <a:p>
+            <a:pPr algn="l">
+              <a:lnSpc>
+                <a:spcPct val="108000"/>
+              </a:lnSpc>
+            </a:pPr>
+            <a:r>
+              <a:rPr sz="850" b="1">
+                <a:solidFill>
+                  <a:srgbClr val="606C7A"/>
+                </a:solidFill>
+                <a:latin typeface="Aptos"/>
+              </a:rPr>
+              <a:t>CLOSING</a:t>
+            </a:r>
+          </a:p>
+        </p:txBody>
+      </p:sp>
+      <p:sp>
+        <p:nvSpPr>
+          <p:cNvPr id="4" name="TextBox 3"/>
+          <p:cNvSpPr txBox="1"/>
+          <p:nvPr/>
+        </p:nvSpPr>
+        <p:spPr>
+          <a:xfrm>
+            <a:off x="10469880" y="347472"/>
+            <a:ext cx="1170432" cy="292608"/>
+          </a:xfrm>
+          <a:prstGeom prst="rect">
+            <a:avLst/>
+          </a:prstGeom>
+          <a:noFill/>
+        </p:spPr>
+        <p:txBody>
+          <a:bodyPr wrap="square" lIns="18288" rIns="18288" tIns="9144" bIns="9144" anchor="t">
+            <a:spAutoFit/>
+          </a:bodyPr>
+          <a:lstStyle/>
+          <a:p>
+            <a:pPr algn="r">
+              <a:lnSpc>
+                <a:spcPct val="108000"/>
+              </a:lnSpc>
+            </a:pPr>
+            <a:r>
+              <a:rPr sz="900" b="0">
+                <a:solidFill>
+                  <a:srgbClr val="606C7A"/>
+                </a:solidFill>
+                <a:latin typeface="PingFang SC"/>
+              </a:rPr>
+              <a:t>收束与问答</a:t>
+            </a:r>
+          </a:p>
+        </p:txBody>
+      </p:sp>
+      <p:sp>
+        <p:nvSpPr>
+          <p:cNvPr id="5" name="TextBox 4"/>
+          <p:cNvSpPr txBox="1"/>
+          <p:nvPr/>
+        </p:nvSpPr>
+        <p:spPr>
+          <a:xfrm>
+            <a:off x="640080" y="960120"/>
+            <a:ext cx="5669280" cy="411480"/>
+          </a:xfrm>
+          <a:prstGeom prst="rect">
+            <a:avLst/>
+          </a:prstGeom>
+          <a:noFill/>
+        </p:spPr>
+        <p:txBody>
+          <a:bodyPr wrap="square" lIns="18288" rIns="18288" tIns="9144" bIns="9144" anchor="t">
+            <a:spAutoFit/>
+          </a:bodyPr>
+          <a:lstStyle/>
+          <a:p>
+            <a:pPr algn="l">
+              <a:lnSpc>
+                <a:spcPct val="108000"/>
+              </a:lnSpc>
+            </a:pPr>
+            <a:r>
+              <a:rPr sz="2400" b="1">
+                <a:solidFill>
+                  <a:srgbClr val="121B27"/>
+                </a:solidFill>
+                <a:latin typeface="PingFang SC"/>
+              </a:rPr>
+              <a:t>我希望西湖看到的是一个完整的人</a:t>
+            </a:r>
+          </a:p>
+        </p:txBody>
+      </p:sp>
+      <p:sp>
+        <p:nvSpPr>
+          <p:cNvPr id="6" name="TextBox 5"/>
+          <p:cNvSpPr txBox="1"/>
+          <p:nvPr/>
+        </p:nvSpPr>
+        <p:spPr>
+          <a:xfrm>
+            <a:off x="658368" y="1572768"/>
+            <a:ext cx="6035040" cy="292608"/>
+          </a:xfrm>
+          <a:prstGeom prst="rect">
+            <a:avLst/>
+          </a:prstGeom>
+          <a:noFill/>
+        </p:spPr>
+        <p:txBody>
+          <a:bodyPr wrap="square" lIns="18288" rIns="18288" tIns="9144" bIns="9144" anchor="t">
+            <a:spAutoFit/>
+          </a:bodyPr>
+          <a:lstStyle/>
+          <a:p>
+            <a:pPr algn="l">
+              <a:lnSpc>
+                <a:spcPct val="108000"/>
+              </a:lnSpc>
+            </a:pPr>
+            <a:r>
+              <a:rPr sz="1300" b="1">
+                <a:solidFill>
+                  <a:srgbClr val="2A3440"/>
+                </a:solidFill>
+                <a:latin typeface="PingFang SC"/>
+              </a:rPr>
+              <a:t>基础扎实，但还在收敛方向；成果不算成熟，但自驱探索和实现能力真实存在。</a:t>
+            </a:r>
+          </a:p>
+        </p:txBody>
+      </p:sp>
+      <p:sp>
+        <p:nvSpPr>
+          <p:cNvPr id="7" name="Rounded Rectangle 6"/>
+          <p:cNvSpPr/>
+          <p:nvPr/>
+        </p:nvSpPr>
+        <p:spPr>
+          <a:xfrm>
+            <a:off x="658368" y="2130552"/>
+            <a:ext cx="5989320" cy="658368"/>
+          </a:xfrm>
+          <a:prstGeom prst="roundRect">
+            <a:avLst/>
+          </a:prstGeom>
+          <a:solidFill>
+            <a:srgbClr val="FFFFFF"/>
+          </a:solidFill>
+          <a:ln w="8890">
+            <a:solidFill>
+              <a:srgbClr val="D8E3EA"/>
+            </a:solidFill>
+          </a:ln>
+        </p:spPr>
+        <p:style>
+          <a:lnRef idx="1">
+            <a:schemeClr val="accent1"/>
+          </a:lnRef>
+          <a:fillRef idx="3">
+            <a:schemeClr val="accent1"/>
+          </a:fillRef>
+          <a:effectRef idx="2">
+            <a:schemeClr val="accent1"/>
+          </a:effectRef>
+          <a:fontRef idx="minor">
+            <a:schemeClr val="lt1"/>
+          </a:fontRef>
+        </p:style>
+        <p:txBody>
+          <a:bodyPr rtlCol="0" anchor="ctr"/>
+          <a:lstStyle/>
+          <a:p>
+            <a:pPr algn="ctr"/>
+          </a:p>
+        </p:txBody>
+      </p:sp>
+      <p:sp>
+        <p:nvSpPr>
+          <p:cNvPr id="8" name="Oval 7"/>
+          <p:cNvSpPr/>
+          <p:nvPr/>
+        </p:nvSpPr>
+        <p:spPr>
+          <a:xfrm>
+            <a:off x="749808" y="2286000"/>
+            <a:ext cx="292608" cy="292608"/>
+          </a:xfrm>
+          <a:prstGeom prst="ellipse">
+            <a:avLst/>
+          </a:prstGeom>
+          <a:solidFill>
+            <a:srgbClr val="127584"/>
+          </a:solidFill>
+          <a:ln>
+            <a:noFill/>
+          </a:ln>
+        </p:spPr>
+        <p:style>
+          <a:lnRef idx="1">
+            <a:schemeClr val="accent1"/>
+          </a:lnRef>
+          <a:fillRef idx="3">
+            <a:schemeClr val="accent1"/>
+          </a:fillRef>
+          <a:effectRef idx="2">
+            <a:schemeClr val="accent1"/>
+          </a:effectRef>
+          <a:fontRef idx="minor">
+            <a:schemeClr val="lt1"/>
+          </a:fontRef>
+        </p:style>
+        <p:txBody>
+          <a:bodyPr rtlCol="0" anchor="ctr"/>
+          <a:lstStyle/>
+          <a:p>
+            <a:pPr algn="ctr"/>
+          </a:p>
+        </p:txBody>
+      </p:sp>
+      <p:sp>
+        <p:nvSpPr>
           <p:cNvPr id="9" name="TextBox 8"/>
           <p:cNvSpPr txBox="1"/>
           <p:nvPr/>
@@ -12680,9 +12756,9 @@
             <a:r>
               <a:rPr sz="1350" b="1">
                 <a:solidFill>
-                  <a:srgbClr val="FFFFFF"/>
-                </a:solidFill>
-                <a:latin typeface="Hiragino Sans GB"/>
+                  <a:srgbClr val="121B27"/>
+                </a:solidFill>
+                <a:latin typeface="PingFang SC"/>
               </a:rPr>
               <a:t>学术底座</a:t>
             </a:r>
@@ -12719,9 +12795,9 @@
             <a:r>
               <a:rPr sz="1030" b="0">
                 <a:solidFill>
-                  <a:srgbClr val="CBDCE0"/>
-                </a:solidFill>
-                <a:latin typeface="Hiragino Sans GB"/>
+                  <a:srgbClr val="606C7A"/>
+                </a:solidFill>
+                <a:latin typeface="PingFang SC"/>
               </a:rPr>
               <a:t>物理与数学课程支撑后续建模和数值训练。</a:t>
             </a:r>
@@ -12730,7 +12806,52 @@
       </p:sp>
       <p:sp>
         <p:nvSpPr>
-          <p:cNvPr id="12" name="Oval 11"/>
+          <p:cNvPr id="12" name="Rounded Rectangle 11"/>
+          <p:cNvSpPr/>
+          <p:nvPr/>
+        </p:nvSpPr>
+        <p:spPr>
+          <a:xfrm>
+            <a:off x="658368" y="3044952"/>
+            <a:ext cx="5989320" cy="658368"/>
+          </a:xfrm>
+          <a:prstGeom prst="roundRect">
+            <a:avLst/>
+          </a:prstGeom>
+          <a:solidFill>
+            <a:srgbClr val="FFFFFF"/>
+          </a:solidFill>
+          <a:ln w="8890">
+            <a:solidFill>
+              <a:srgbClr val="D8E3EA"/>
+            </a:solidFill>
+          </a:ln>
+        </p:spPr>
+        <p:style>
+          <a:lnRef idx="1">
+            <a:schemeClr val="accent1"/>
+          </a:lnRef>
+          <a:fillRef idx="3">
+            <a:schemeClr val="accent1"/>
+          </a:fillRef>
+          <a:effectRef idx="2">
+            <a:schemeClr val="accent1"/>
+          </a:effectRef>
+          <a:fontRef idx="minor">
+            <a:schemeClr val="lt1"/>
+          </a:fontRef>
+        </p:style>
+        <p:txBody>
+          <a:bodyPr rtlCol="0" anchor="ctr"/>
+          <a:lstStyle/>
+          <a:p>
+            <a:pPr algn="ctr"/>
+          </a:p>
+        </p:txBody>
+      </p:sp>
+      <p:sp>
+        <p:nvSpPr>
+          <p:cNvPr id="13" name="Oval 12"/>
           <p:cNvSpPr/>
           <p:nvPr/>
         </p:nvSpPr>
@@ -12773,7 +12894,7 @@
       </p:sp>
       <p:sp>
         <p:nvSpPr>
-          <p:cNvPr id="13" name="TextBox 12"/>
+          <p:cNvPr id="14" name="TextBox 13"/>
           <p:cNvSpPr txBox="1"/>
           <p:nvPr/>
         </p:nvSpPr>
@@ -12812,7 +12933,7 @@
       </p:sp>
       <p:sp>
         <p:nvSpPr>
-          <p:cNvPr id="14" name="TextBox 13"/>
+          <p:cNvPr id="15" name="TextBox 14"/>
           <p:cNvSpPr txBox="1"/>
           <p:nvPr/>
         </p:nvSpPr>
@@ -12840,9 +12961,9 @@
             <a:r>
               <a:rPr sz="1350" b="1">
                 <a:solidFill>
-                  <a:srgbClr val="FFFFFF"/>
-                </a:solidFill>
-                <a:latin typeface="Hiragino Sans GB"/>
+                  <a:srgbClr val="121B27"/>
+                </a:solidFill>
+                <a:latin typeface="PingFang SC"/>
               </a:rPr>
               <a:t>自驱探索</a:t>
             </a:r>
@@ -12851,7 +12972,7 @@
       </p:sp>
       <p:sp>
         <p:nvSpPr>
-          <p:cNvPr id="15" name="TextBox 14"/>
+          <p:cNvPr id="16" name="TextBox 15"/>
           <p:cNvSpPr txBox="1"/>
           <p:nvPr/>
         </p:nvSpPr>
@@ -12879,9 +13000,9 @@
             <a:r>
               <a:rPr sz="1030" b="0">
                 <a:solidFill>
-                  <a:srgbClr val="CBDCE0"/>
-                </a:solidFill>
-                <a:latin typeface="Hiragino Sans GB"/>
+                  <a:srgbClr val="606C7A"/>
+                </a:solidFill>
+                <a:latin typeface="PingFang SC"/>
               </a:rPr>
               <a:t>从徒步旅行到主动做项目，习惯先行动再迭代。</a:t>
             </a:r>
@@ -12890,7 +13011,52 @@
       </p:sp>
       <p:sp>
         <p:nvSpPr>
-          <p:cNvPr id="16" name="Oval 15"/>
+          <p:cNvPr id="17" name="Rounded Rectangle 16"/>
+          <p:cNvSpPr/>
+          <p:nvPr/>
+        </p:nvSpPr>
+        <p:spPr>
+          <a:xfrm>
+            <a:off x="658368" y="3959352"/>
+            <a:ext cx="5989320" cy="658368"/>
+          </a:xfrm>
+          <a:prstGeom prst="roundRect">
+            <a:avLst/>
+          </a:prstGeom>
+          <a:solidFill>
+            <a:srgbClr val="FFFFFF"/>
+          </a:solidFill>
+          <a:ln w="8890">
+            <a:solidFill>
+              <a:srgbClr val="D8E3EA"/>
+            </a:solidFill>
+          </a:ln>
+        </p:spPr>
+        <p:style>
+          <a:lnRef idx="1">
+            <a:schemeClr val="accent1"/>
+          </a:lnRef>
+          <a:fillRef idx="3">
+            <a:schemeClr val="accent1"/>
+          </a:fillRef>
+          <a:effectRef idx="2">
+            <a:schemeClr val="accent1"/>
+          </a:effectRef>
+          <a:fontRef idx="minor">
+            <a:schemeClr val="lt1"/>
+          </a:fontRef>
+        </p:style>
+        <p:txBody>
+          <a:bodyPr rtlCol="0" anchor="ctr"/>
+          <a:lstStyle/>
+          <a:p>
+            <a:pPr algn="ctr"/>
+          </a:p>
+        </p:txBody>
+      </p:sp>
+      <p:sp>
+        <p:nvSpPr>
+          <p:cNvPr id="18" name="Oval 17"/>
           <p:cNvSpPr/>
           <p:nvPr/>
         </p:nvSpPr>
@@ -12933,7 +13099,7 @@
       </p:sp>
       <p:sp>
         <p:nvSpPr>
-          <p:cNvPr id="17" name="TextBox 16"/>
+          <p:cNvPr id="19" name="TextBox 18"/>
           <p:cNvSpPr txBox="1"/>
           <p:nvPr/>
         </p:nvSpPr>
@@ -12972,7 +13138,7 @@
       </p:sp>
       <p:sp>
         <p:nvSpPr>
-          <p:cNvPr id="18" name="TextBox 17"/>
+          <p:cNvPr id="20" name="TextBox 19"/>
           <p:cNvSpPr txBox="1"/>
           <p:nvPr/>
         </p:nvSpPr>
@@ -13000,9 +13166,9 @@
             <a:r>
               <a:rPr sz="1350" b="1">
                 <a:solidFill>
-                  <a:srgbClr val="FFFFFF"/>
-                </a:solidFill>
-                <a:latin typeface="Hiragino Sans GB"/>
+                  <a:srgbClr val="121B27"/>
+                </a:solidFill>
+                <a:latin typeface="PingFang SC"/>
               </a:rPr>
               <a:t>可复现能力</a:t>
             </a:r>
@@ -13011,7 +13177,7 @@
       </p:sp>
       <p:sp>
         <p:nvSpPr>
-          <p:cNvPr id="19" name="TextBox 18"/>
+          <p:cNvPr id="21" name="TextBox 20"/>
           <p:cNvSpPr txBox="1"/>
           <p:nvPr/>
         </p:nvSpPr>
@@ -13039,9 +13205,9 @@
             <a:r>
               <a:rPr sz="1030" b="0">
                 <a:solidFill>
-                  <a:srgbClr val="CBDCE0"/>
-                </a:solidFill>
-                <a:latin typeface="Hiragino Sans GB"/>
+                  <a:srgbClr val="606C7A"/>
+                </a:solidFill>
+                <a:latin typeface="PingFang SC"/>
               </a:rPr>
               <a:t>用代码、网页和文档沉淀问题、方法和结果。</a:t>
             </a:r>
@@ -13050,7 +13216,7 @@
       </p:sp>
       <p:sp>
         <p:nvSpPr>
-          <p:cNvPr id="20" name="Rounded Rectangle 19"/>
+          <p:cNvPr id="22" name="Rounded Rectangle 21"/>
           <p:cNvSpPr/>
           <p:nvPr/>
         </p:nvSpPr>
@@ -13065,8 +13231,10 @@
           <a:solidFill>
             <a:srgbClr val="E8F1F2"/>
           </a:solidFill>
-          <a:ln>
-            <a:noFill/>
+          <a:ln w="8890">
+            <a:solidFill>
+              <a:srgbClr val="C9DCDF"/>
+            </a:solidFill>
           </a:ln>
         </p:spPr>
         <p:style>
@@ -13093,7 +13261,7 @@
       </p:sp>
       <p:sp>
         <p:nvSpPr>
-          <p:cNvPr id="21" name="TextBox 20"/>
+          <p:cNvPr id="23" name="TextBox 22"/>
           <p:cNvSpPr txBox="1"/>
           <p:nvPr/>
         </p:nvSpPr>
@@ -13123,7 +13291,7 @@
                 <a:solidFill>
                   <a:srgbClr val="127584"/>
                 </a:solidFill>
-                <a:latin typeface="Hiragino Sans GB"/>
+                <a:latin typeface="PingFang SC"/>
               </a:rPr>
               <a:t>汇报收束</a:t>
             </a:r>
@@ -13132,7 +13300,7 @@
       </p:sp>
       <p:sp>
         <p:nvSpPr>
-          <p:cNvPr id="22" name="TextBox 21"/>
+          <p:cNvPr id="24" name="TextBox 23"/>
           <p:cNvSpPr txBox="1"/>
           <p:nvPr/>
         </p:nvSpPr>
@@ -13162,7 +13330,7 @@
                 <a:solidFill>
                   <a:srgbClr val="111F2B"/>
                 </a:solidFill>
-                <a:latin typeface="Hiragino Sans GB"/>
+                <a:latin typeface="PingFang SC"/>
               </a:rPr>
               <a:t>把探索未知的习惯，
 转化为扎实、可复现的科研能力。</a:t>
@@ -13172,7 +13340,7 @@
       </p:sp>
       <p:sp>
         <p:nvSpPr>
-          <p:cNvPr id="23" name="TextBox 22"/>
+          <p:cNvPr id="25" name="TextBox 24"/>
           <p:cNvSpPr txBox="1"/>
           <p:nvPr/>
         </p:nvSpPr>
@@ -13202,7 +13370,7 @@
                 <a:solidFill>
                   <a:srgbClr val="2A3440"/>
                 </a:solidFill>
-                <a:latin typeface="Hiragino Sans GB"/>
+                <a:latin typeface="PingFang SC"/>
               </a:rPr>
               <a:t>希望在西湖接受更严格、长期的科研训练。</a:t>
             </a:r>
@@ -13211,7 +13379,7 @@
       </p:sp>
       <p:sp>
         <p:nvSpPr>
-          <p:cNvPr id="24" name="TextBox 23"/>
+          <p:cNvPr id="26" name="TextBox 25"/>
           <p:cNvSpPr txBox="1"/>
           <p:nvPr/>
         </p:nvSpPr>
@@ -13250,15 +13418,50 @@
           </a:p>
         </p:txBody>
       </p:sp>
-      <p:sp>
-        <p:nvSpPr>
-          <p:cNvPr id="25" name="TextBox 24"/>
-          <p:cNvSpPr txBox="1"/>
-          <p:nvPr/>
-        </p:nvSpPr>
-        <p:spPr>
-          <a:xfrm>
-            <a:off x="640080" y="6153912"/>
+      <p:cxnSp>
+        <p:nvCxnSpPr>
+          <p:cNvPr id="27" name="Connector 26"/>
+          <p:cNvCxnSpPr/>
+          <p:nvPr/>
+        </p:nvCxnSpPr>
+        <p:spPr>
+          <a:xfrm>
+            <a:off x="658368" y="5870448"/>
+            <a:ext cx="5971032" cy="0"/>
+          </a:xfrm>
+          <a:prstGeom prst="line">
+            <a:avLst/>
+          </a:prstGeom>
+          <a:ln w="10160">
+            <a:solidFill>
+              <a:srgbClr val="D7DEE6"/>
+            </a:solidFill>
+          </a:ln>
+        </p:spPr>
+        <p:style>
+          <a:lnRef idx="2">
+            <a:schemeClr val="accent1"/>
+          </a:lnRef>
+          <a:fillRef idx="0">
+            <a:schemeClr val="accent1"/>
+          </a:fillRef>
+          <a:effectRef idx="1">
+            <a:schemeClr val="accent1"/>
+          </a:effectRef>
+          <a:fontRef idx="minor">
+            <a:schemeClr val="tx1"/>
+          </a:fontRef>
+        </p:style>
+      </p:cxnSp>
+      <p:sp>
+        <p:nvSpPr>
+          <p:cNvPr id="28" name="TextBox 27"/>
+          <p:cNvSpPr txBox="1"/>
+          <p:nvPr/>
+        </p:nvSpPr>
+        <p:spPr>
+          <a:xfrm>
+            <a:off x="658368" y="6053328"/>
             <a:ext cx="2560320" cy="256032"/>
           </a:xfrm>
           <a:prstGeom prst="rect">
@@ -13280,7 +13483,7 @@
             <a:r>
               <a:rPr sz="1000" b="1">
                 <a:solidFill>
-                  <a:srgbClr val="A9BDC2"/>
+                  <a:srgbClr val="127584"/>
                 </a:solidFill>
                 <a:latin typeface="Aptos"/>
               </a:rPr>
@@ -13291,13 +13494,13 @@
       </p:sp>
       <p:sp>
         <p:nvSpPr>
-          <p:cNvPr id="26" name="TextBox 25"/>
-          <p:cNvSpPr txBox="1"/>
-          <p:nvPr/>
-        </p:nvSpPr>
-        <p:spPr>
-          <a:xfrm>
-            <a:off x="10287000" y="6153912"/>
+          <p:cNvPr id="29" name="TextBox 28"/>
+          <p:cNvSpPr txBox="1"/>
+          <p:nvPr/>
+        </p:nvSpPr>
+        <p:spPr>
+          <a:xfrm>
+            <a:off x="10287000" y="6053328"/>
             <a:ext cx="1234440" cy="256032"/>
           </a:xfrm>
           <a:prstGeom prst="rect">
@@ -13319,9 +13522,9 @@
             <a:r>
               <a:rPr sz="1000" b="1">
                 <a:solidFill>
-                  <a:srgbClr val="A9BDC2"/>
-                </a:solidFill>
-                <a:latin typeface="Hiragino Sans GB"/>
+                  <a:srgbClr val="606C7A"/>
+                </a:solidFill>
+                <a:latin typeface="PingFang SC"/>
               </a:rPr>
               <a:t>齐恒 · A5</a:t>
             </a:r>

</xml_diff>